<commit_message>
Add slipstream boost & title/hero shot fitting
Implement proximity-based slipstream boost recovery and add build-time 2D fitting for title/hero shots.

- Game: add slipstream constants, update_slipstream(), init/reset, and call from update(); trailing car charges for 10 frames (~0.5s) and recovers 8 boost per fixed update while within the configured angular gap and lane offset (24 units); visual brightening reused for indicator; does not stack with existing catch-up recovery.
- Render: use bright colors when slipstream active.
- Tools: mkhero.py and mktitle.py now compute per-shot source/fitted bounds and scale, fit geometry into reserved viewports, emit shot metadata/comments in generated headers, and validate fitted bounds.
- Docs/binaries: update English/Japanese manuals and progress notes; rebuilt dist/wdrfrace.xdf and related PDFs/PPTX.
</commit_message>
<xml_diff>
--- a/doc/manual-en.pptx
+++ b/doc/manual-en.pptx
@@ -2,28 +2,29 @@
 <file path=ppt/presentation.xml><?xml version="1.0" encoding="utf-8"?>
 <p:presentation xmlns:p="http://schemas.openxmlformats.org/presentationml/2006/main">
   <p:sldMasterIdLst>
-    <p:sldMasterId xmlns:r="http://schemas.openxmlformats.org/officeDocument/2006/relationships" id="2147483648" r:id="Rc1ac6601102b49a9"/>
+    <p:sldMasterId xmlns:r="http://schemas.openxmlformats.org/officeDocument/2006/relationships" id="2147483648" r:id="R37bdc853ecf042e3"/>
   </p:sldMasterIdLst>
   <p:notesMasterIdLst>
-    <p:notesMasterId xmlns:r="http://schemas.openxmlformats.org/officeDocument/2006/relationships" r:id="Rede436ae17984c9f"/>
+    <p:notesMasterId xmlns:r="http://schemas.openxmlformats.org/officeDocument/2006/relationships" r:id="Rb988c1c758884836"/>
   </p:notesMasterIdLst>
   <p:sldIdLst>
-    <p:sldId xmlns:r="http://schemas.openxmlformats.org/officeDocument/2006/relationships" id="256" r:id="R83fe958c123042f3"/>
-    <p:sldId xmlns:r="http://schemas.openxmlformats.org/officeDocument/2006/relationships" id="257" r:id="R11913c95a8924c0c"/>
-    <p:sldId xmlns:r="http://schemas.openxmlformats.org/officeDocument/2006/relationships" id="258" r:id="Rc1439d1ad4a74bfb"/>
-    <p:sldId xmlns:r="http://schemas.openxmlformats.org/officeDocument/2006/relationships" id="259" r:id="R1d7fc55aa4e04082"/>
-    <p:sldId xmlns:r="http://schemas.openxmlformats.org/officeDocument/2006/relationships" id="260" r:id="R8a659f097eca4b63"/>
-    <p:sldId xmlns:r="http://schemas.openxmlformats.org/officeDocument/2006/relationships" id="261" r:id="R91438dfb6a084497"/>
-    <p:sldId xmlns:r="http://schemas.openxmlformats.org/officeDocument/2006/relationships" id="262" r:id="R7cf6fc4918db4ffd"/>
-    <p:sldId xmlns:r="http://schemas.openxmlformats.org/officeDocument/2006/relationships" id="263" r:id="Re1efbea7e7ae4f75"/>
-    <p:sldId xmlns:r="http://schemas.openxmlformats.org/officeDocument/2006/relationships" id="264" r:id="R3d7d6f44161f4576"/>
-    <p:sldId xmlns:r="http://schemas.openxmlformats.org/officeDocument/2006/relationships" id="265" r:id="Re816ff369d74404d"/>
-    <p:sldId xmlns:r="http://schemas.openxmlformats.org/officeDocument/2006/relationships" id="266" r:id="R9847bdf7f8054bb7"/>
-    <p:sldId xmlns:r="http://schemas.openxmlformats.org/officeDocument/2006/relationships" id="267" r:id="R2cdacc4b5952411c"/>
-    <p:sldId xmlns:r="http://schemas.openxmlformats.org/officeDocument/2006/relationships" id="268" r:id="R9ed2c6c30e7a408f"/>
-    <p:sldId xmlns:r="http://schemas.openxmlformats.org/officeDocument/2006/relationships" id="269" r:id="R37b263090df34422"/>
-    <p:sldId xmlns:r="http://schemas.openxmlformats.org/officeDocument/2006/relationships" id="270" r:id="Re351b05ae19d43ae"/>
-    <p:sldId xmlns:r="http://schemas.openxmlformats.org/officeDocument/2006/relationships" id="271" r:id="Re43d1b2885094a38"/>
+    <p:sldId xmlns:r="http://schemas.openxmlformats.org/officeDocument/2006/relationships" id="256" r:id="R9df5cd7233304a0a"/>
+    <p:sldId xmlns:r="http://schemas.openxmlformats.org/officeDocument/2006/relationships" id="257" r:id="R15be0a8a703f43b9"/>
+    <p:sldId xmlns:r="http://schemas.openxmlformats.org/officeDocument/2006/relationships" id="258" r:id="Rdabf6619d4964a22"/>
+    <p:sldId xmlns:r="http://schemas.openxmlformats.org/officeDocument/2006/relationships" id="259" r:id="R22d3a13c32fe436b"/>
+    <p:sldId xmlns:r="http://schemas.openxmlformats.org/officeDocument/2006/relationships" id="260" r:id="R0436017529b64e11"/>
+    <p:sldId xmlns:r="http://schemas.openxmlformats.org/officeDocument/2006/relationships" id="261" r:id="R6825ecddc2a744ad"/>
+    <p:sldId xmlns:r="http://schemas.openxmlformats.org/officeDocument/2006/relationships" id="262" r:id="R1147ceedc1d04ddc"/>
+    <p:sldId xmlns:r="http://schemas.openxmlformats.org/officeDocument/2006/relationships" id="263" r:id="R29dd3ec2e0a64665"/>
+    <p:sldId xmlns:r="http://schemas.openxmlformats.org/officeDocument/2006/relationships" id="264" r:id="R83b626e4209f4478"/>
+    <p:sldId xmlns:r="http://schemas.openxmlformats.org/officeDocument/2006/relationships" id="265" r:id="R5c83850916fe45ab"/>
+    <p:sldId xmlns:r="http://schemas.openxmlformats.org/officeDocument/2006/relationships" id="266" r:id="R0ec3f0e66f4040a4"/>
+    <p:sldId xmlns:r="http://schemas.openxmlformats.org/officeDocument/2006/relationships" id="267" r:id="Rc1bb467c51dc4fcc"/>
+    <p:sldId xmlns:r="http://schemas.openxmlformats.org/officeDocument/2006/relationships" id="268" r:id="R5f94d270969e4e4f"/>
+    <p:sldId xmlns:r="http://schemas.openxmlformats.org/officeDocument/2006/relationships" id="269" r:id="Rabd89df43d3e4073"/>
+    <p:sldId xmlns:r="http://schemas.openxmlformats.org/officeDocument/2006/relationships" id="270" r:id="R6faf9c70c1e24efa"/>
+    <p:sldId xmlns:r="http://schemas.openxmlformats.org/officeDocument/2006/relationships" id="271" r:id="R70b75395420c4495"/>
+    <p:sldId xmlns:r="http://schemas.openxmlformats.org/officeDocument/2006/relationships" id="272" r:id="Raf652a4f2dbd422f"/>
   </p:sldIdLst>
   <p:sldSz cx="11430000" cy="8572500"/>
   <p:notesSz cx="6858000" cy="9144000"/>
@@ -945,6 +946,72 @@
 </p:notes>
 </file>
 
+<file path=ppt/notesSlides/notesSlide17.xml><?xml version="1.0" encoding="utf-8"?>
+<p:notes xmlns:p="http://schemas.openxmlformats.org/presentationml/2006/main">
+  <p:cSld>
+    <p:spTree>
+      <p:nvGrpSpPr>
+        <p:cNvPr id="1" name=""/>
+        <p:cNvGrpSpPr/>
+        <p:nvPr/>
+      </p:nvGrpSpPr>
+      <p:grpSpPr>
+        <a:xfrm xmlns:a="http://schemas.openxmlformats.org/drawingml/2006/main"/>
+      </p:grpSpPr>
+      <p:sp>
+        <p:nvSpPr>
+          <p:cNvPr id="2" name="Slide Image Placeholder 1"/>
+          <p:cNvSpPr>
+            <a:spLocks xmlns:a="http://schemas.openxmlformats.org/drawingml/2006/main" noGrp="1"/>
+          </p:cNvSpPr>
+          <p:nvPr>
+            <p:ph type="sldImg" idx="0"/>
+          </p:nvPr>
+        </p:nvSpPr>
+        <p:spPr/>
+      </p:sp>
+      <p:sp>
+        <p:nvSpPr>
+          <p:cNvPr id="3" name="Notes Placeholder 2"/>
+          <p:cNvSpPr>
+            <a:spLocks xmlns:a="http://schemas.openxmlformats.org/drawingml/2006/main" noGrp="1"/>
+          </p:cNvSpPr>
+          <p:nvPr>
+            <p:ph type="body" idx="1"/>
+          </p:nvPr>
+        </p:nvSpPr>
+        <p:spPr/>
+        <p:txBody>
+          <a:bodyPr xmlns:a="http://schemas.openxmlformats.org/drawingml/2006/main"/>
+          <a:lstStyle xmlns:a="http://schemas.openxmlformats.org/drawingml/2006/main"/>
+          <a:p xmlns:a="http://schemas.openxmlformats.org/drawingml/2006/main"/>
+        </p:txBody>
+      </p:sp>
+      <p:sp>
+        <p:nvSpPr>
+          <p:cNvPr id="4" name="Slide Number Placeholder 3"/>
+          <p:cNvSpPr>
+            <a:spLocks xmlns:a="http://schemas.openxmlformats.org/drawingml/2006/main" noGrp="1"/>
+          </p:cNvSpPr>
+          <p:nvPr>
+            <p:ph type="sldNum" idx="5"/>
+          </p:nvPr>
+        </p:nvSpPr>
+        <p:spPr/>
+        <p:txBody>
+          <a:bodyPr xmlns:a="http://schemas.openxmlformats.org/drawingml/2006/main"/>
+          <a:lstStyle xmlns:a="http://schemas.openxmlformats.org/drawingml/2006/main"/>
+          <a:p xmlns:a="http://schemas.openxmlformats.org/drawingml/2006/main"/>
+        </p:txBody>
+      </p:sp>
+    </p:spTree>
+  </p:cSld>
+  <p:clrMapOvr>
+    <a:masterClrMapping xmlns:a="http://schemas.openxmlformats.org/drawingml/2006/main"/>
+  </p:clrMapOvr>
+</p:notes>
+</file>
+
 <file path=ppt/notesSlides/notesSlide2.xml><?xml version="1.0" encoding="utf-8"?>
 <p:notes xmlns:p="http://schemas.openxmlformats.org/presentationml/2006/main">
   <p:cSld>
@@ -1511,7 +1578,7 @@
   </p:cSld>
   <p:clrMap bg1="lt1" tx1="dk1" bg2="lt2" tx2="dk2" accent1="accent1" accent2="accent2" accent3="accent3" accent4="accent4" accent5="accent5" accent6="accent6" hlink="hlink" folHlink="folHlink"/>
   <p:sldLayoutIdLst>
-    <p:sldLayoutId xmlns:r="http://schemas.openxmlformats.org/officeDocument/2006/relationships" id="2147483649" r:id="Rf1b8818b0b5d428f"/>
+    <p:sldLayoutId xmlns:r="http://schemas.openxmlformats.org/officeDocument/2006/relationships" id="2147483649" r:id="Rbcddfbd9f9534d29"/>
   </p:sldLayoutIdLst>
   <p:txStyles>
     <p:titleStyle>
@@ -3172,7 +3239,7 @@
                   <a:srgbClr val="F3FBFF"/>
                 </a:solidFill>
               </a:rPr>
-              <a:t>Contact is not an accident; it is a comeback weapon</a:t>
+              <a:t>Contact and pursuit are comeback weapons</a:t>
             </a:r>
           </a:p>
         </p:txBody>
@@ -4084,7 +4151,7 @@
                   <a:srgbClr val="F3FBFF"/>
                 </a:solidFill>
               </a:rPr>
-              <a:t>A trailing car slowly recovers boost as the gap grows. Speed is never automatic; the driver decides where to spend the energy.</a:t>
+              <a:t>At close range, hold the leader's lane for 0.5 sec to recover BOOST. Large gaps use catch-up recovery. Neither adds automatic speed.</a:t>
             </a:r>
           </a:p>
         </p:txBody>
@@ -4332,6 +4399,89 @@
                 </a:solidFill>
               </a:rPr>
               <a:t>X68000 / 3 LAPS / 2 CARS</a:t>
+            </a:r>
+          </a:p>
+        </p:txBody>
+      </p:sp>
+      <p:sp>
+        <p:nvSpPr>
+          <p:cNvPr id="37" name="slip-label-cover">
+            <a:extLst xmlns:a="http://schemas.openxmlformats.org/drawingml/2006/main">
+              <a:ext uri="{FF2B5EF4-FFF2-40B4-BE49-F238E27FC236}">
+                <a16:creationId xmlns:a16="http://schemas.microsoft.com/office/drawing/2014/main" id="{F7364464-DD75-4E01-9D24-120BEDDFA8DC}"/>
+              </a:ext>
+            </a:extLst>
+          </p:cNvPr>
+          <p:cNvSpPr>
+            <a:spLocks xmlns:a="http://schemas.openxmlformats.org/drawingml/2006/main" noGrp="1"/>
+          </p:cNvSpPr>
+          <p:nvPr/>
+        </p:nvSpPr>
+        <p:spPr>
+          <a:xfrm xmlns:a="http://schemas.openxmlformats.org/drawingml/2006/main">
+            <a:off x="6000750" y="1885950"/>
+            <a:ext cx="4476750" cy="685800"/>
+          </a:xfrm>
+          <a:prstGeom xmlns:a="http://schemas.openxmlformats.org/drawingml/2006/main" prst="rect">
+            <a:avLst/>
+          </a:prstGeom>
+          <a:solidFill xmlns:a="http://schemas.openxmlformats.org/drawingml/2006/main">
+            <a:srgbClr val="05070A"/>
+          </a:solidFill>
+          <a:ln xmlns:a="http://schemas.openxmlformats.org/drawingml/2006/main" w="0">
+            <a:solidFill>
+              <a:srgbClr val="05070A"/>
+            </a:solidFill>
+            <a:prstDash val="solid"/>
+          </a:ln>
+        </p:spPr>
+      </p:sp>
+      <p:sp>
+        <p:nvSpPr>
+          <p:cNvPr id="38" name="slip-label">
+            <a:extLst xmlns:a="http://schemas.openxmlformats.org/drawingml/2006/main">
+              <a:ext uri="{FF2B5EF4-FFF2-40B4-BE49-F238E27FC236}">
+                <a16:creationId xmlns:a16="http://schemas.microsoft.com/office/drawing/2014/main" id="{F7580180-0D85-42D0-80DF-1E289B5CBA73}"/>
+              </a:ext>
+            </a:extLst>
+          </p:cNvPr>
+          <p:cNvSpPr>
+            <a:spLocks xmlns:a="http://schemas.openxmlformats.org/drawingml/2006/main" noGrp="1"/>
+          </p:cNvSpPr>
+          <p:nvPr/>
+        </p:nvSpPr>
+        <p:spPr>
+          <a:xfrm xmlns:a="http://schemas.openxmlformats.org/drawingml/2006/main">
+            <a:off x="6172200" y="1943100"/>
+            <a:ext cx="4095750" cy="514350"/>
+          </a:xfrm>
+          <a:prstGeom xmlns:a="http://schemas.openxmlformats.org/drawingml/2006/main" prst="rect">
+            <a:avLst/>
+          </a:prstGeom>
+          <a:noFill xmlns:a="http://schemas.openxmlformats.org/drawingml/2006/main"/>
+          <a:ln xmlns:a="http://schemas.openxmlformats.org/drawingml/2006/main" w="0">
+            <a:noFill/>
+            <a:prstDash val="solid"/>
+          </a:ln>
+        </p:spPr>
+        <p:txBody>
+          <a:bodyPr xmlns:a="http://schemas.openxmlformats.org/drawingml/2006/main" anchor="ctr"/>
+          <a:lstStyle xmlns:a="http://schemas.openxmlformats.org/drawingml/2006/main"/>
+          <a:p xmlns:a="http://schemas.openxmlformats.org/drawingml/2006/main">
+            <a:pPr algn="l">
+              <a:defRPr sz="1725" b="1">
+                <a:solidFill>
+                  <a:srgbClr val="00E6E6"/>
+                </a:solidFill>
+              </a:defRPr>
+            </a:pPr>
+            <a:r>
+              <a:rPr sz="1725" b="1">
+                <a:solidFill>
+                  <a:srgbClr val="00E6E6"/>
+                </a:solidFill>
+              </a:rPr>
+              <a:t>SLIPSTREAM + CATCH-UP</a:t>
             </a:r>
           </a:p>
         </p:txBody>
@@ -10819,6 +10969,1370 @@
 <file path=ppt/slides/slide16.xml><?xml version="1.0" encoding="utf-8"?>
 <p:sld xmlns:p="http://schemas.openxmlformats.org/presentationml/2006/main">
   <p:cSld>
+    <p:spTree>
+      <p:nvGrpSpPr>
+        <p:cNvPr id="1" name=""/>
+        <p:cNvGrpSpPr/>
+        <p:nvPr/>
+      </p:nvGrpSpPr>
+      <p:grpSpPr>
+        <a:xfrm xmlns:a="http://schemas.openxmlformats.org/drawingml/2006/main"/>
+      </p:grpSpPr>
+      <p:sp>
+        <p:nvSpPr>
+          <p:cNvPr id="32" name="background">
+            <a:extLst xmlns:a="http://schemas.openxmlformats.org/drawingml/2006/main">
+              <a:ext uri="{FF2B5EF4-FFF2-40B4-BE49-F238E27FC236}">
+                <a16:creationId xmlns:a16="http://schemas.microsoft.com/office/drawing/2014/main" id="{1ED7CC39-93BE-447D-9A12-9156D246EA28}"/>
+              </a:ext>
+            </a:extLst>
+          </p:cNvPr>
+          <p:cNvSpPr>
+            <a:spLocks xmlns:a="http://schemas.openxmlformats.org/drawingml/2006/main" noGrp="1"/>
+          </p:cNvSpPr>
+          <p:nvPr/>
+        </p:nvSpPr>
+        <p:spPr>
+          <a:xfrm xmlns:a="http://schemas.openxmlformats.org/drawingml/2006/main">
+            <a:off x="0" y="0"/>
+            <a:ext cx="11430000" cy="8572500"/>
+          </a:xfrm>
+          <a:prstGeom xmlns:a="http://schemas.openxmlformats.org/drawingml/2006/main" prst="rect">
+            <a:avLst/>
+          </a:prstGeom>
+          <a:solidFill xmlns:a="http://schemas.openxmlformats.org/drawingml/2006/main">
+            <a:srgbClr val="05070A"/>
+          </a:solidFill>
+          <a:ln xmlns:a="http://schemas.openxmlformats.org/drawingml/2006/main" w="0">
+            <a:solidFill>
+              <a:srgbClr val="05070A"/>
+            </a:solidFill>
+            <a:prstDash val="solid"/>
+          </a:ln>
+        </p:spPr>
+      </p:sp>
+      <p:sp>
+        <p:nvSpPr>
+          <p:cNvPr id="2" name="top-accent">
+            <a:extLst xmlns:a="http://schemas.openxmlformats.org/drawingml/2006/main">
+              <a:ext uri="{FF2B5EF4-FFF2-40B4-BE49-F238E27FC236}">
+                <a16:creationId xmlns:a16="http://schemas.microsoft.com/office/drawing/2014/main" id="{388756C0-F767-44D9-8F57-4E031B055265}"/>
+              </a:ext>
+            </a:extLst>
+          </p:cNvPr>
+          <p:cNvSpPr>
+            <a:spLocks xmlns:a="http://schemas.openxmlformats.org/drawingml/2006/main" noGrp="1"/>
+          </p:cNvSpPr>
+          <p:nvPr/>
+        </p:nvSpPr>
+        <p:spPr>
+          <a:xfrm xmlns:a="http://schemas.openxmlformats.org/drawingml/2006/main">
+            <a:off x="0" y="0"/>
+            <a:ext cx="11430000" cy="76200"/>
+          </a:xfrm>
+          <a:prstGeom xmlns:a="http://schemas.openxmlformats.org/drawingml/2006/main" prst="rect">
+            <a:avLst/>
+          </a:prstGeom>
+          <a:solidFill xmlns:a="http://schemas.openxmlformats.org/drawingml/2006/main">
+            <a:srgbClr val="FF35D3"/>
+          </a:solidFill>
+          <a:ln xmlns:a="http://schemas.openxmlformats.org/drawingml/2006/main" w="0">
+            <a:solidFill>
+              <a:srgbClr val="FF35D3"/>
+            </a:solidFill>
+            <a:prstDash val="solid"/>
+          </a:ln>
+        </p:spPr>
+      </p:sp>
+      <p:sp>
+        <p:nvSpPr>
+          <p:cNvPr id="3" name="section">
+            <a:extLst xmlns:a="http://schemas.openxmlformats.org/drawingml/2006/main">
+              <a:ext uri="{FF2B5EF4-FFF2-40B4-BE49-F238E27FC236}">
+                <a16:creationId xmlns:a16="http://schemas.microsoft.com/office/drawing/2014/main" id="{059A6E36-ACAF-45A4-817B-F50DC9778FF7}"/>
+              </a:ext>
+            </a:extLst>
+          </p:cNvPr>
+          <p:cNvSpPr>
+            <a:spLocks xmlns:a="http://schemas.openxmlformats.org/drawingml/2006/main" noGrp="1"/>
+          </p:cNvSpPr>
+          <p:nvPr/>
+        </p:nvSpPr>
+        <p:spPr>
+          <a:xfrm xmlns:a="http://schemas.openxmlformats.org/drawingml/2006/main">
+            <a:off x="609600" y="209550"/>
+            <a:ext cx="6667500" cy="400050"/>
+          </a:xfrm>
+          <a:prstGeom xmlns:a="http://schemas.openxmlformats.org/drawingml/2006/main" prst="rect">
+            <a:avLst/>
+          </a:prstGeom>
+          <a:noFill xmlns:a="http://schemas.openxmlformats.org/drawingml/2006/main"/>
+          <a:ln xmlns:a="http://schemas.openxmlformats.org/drawingml/2006/main" w="0">
+            <a:noFill/>
+            <a:prstDash val="solid"/>
+          </a:ln>
+        </p:spPr>
+        <p:txBody>
+          <a:bodyPr xmlns:a="http://schemas.openxmlformats.org/drawingml/2006/main" anchor="ctr"/>
+          <a:lstStyle xmlns:a="http://schemas.openxmlformats.org/drawingml/2006/main"/>
+          <a:p xmlns:a="http://schemas.openxmlformats.org/drawingml/2006/main">
+            <a:pPr algn="l">
+              <a:defRPr sz="1350" b="1">
+                <a:solidFill>
+                  <a:srgbClr val="FF35D3"/>
+                </a:solidFill>
+              </a:defRPr>
+            </a:pPr>
+            <a:r>
+              <a:rPr sz="1350" b="1">
+                <a:solidFill>
+                  <a:srgbClr val="FF35D3"/>
+                </a:solidFill>
+              </a:rPr>
+              <a:t>PART 2 / SLIPSTREAM</a:t>
+            </a:r>
+          </a:p>
+        </p:txBody>
+      </p:sp>
+      <p:sp>
+        <p:nvSpPr>
+          <p:cNvPr id="4" name="header-rule">
+            <a:extLst xmlns:a="http://schemas.openxmlformats.org/drawingml/2006/main">
+              <a:ext uri="{FF2B5EF4-FFF2-40B4-BE49-F238E27FC236}">
+                <a16:creationId xmlns:a16="http://schemas.microsoft.com/office/drawing/2014/main" id="{27B7C246-716B-473D-95C6-CD2185E946B5}"/>
+              </a:ext>
+            </a:extLst>
+          </p:cNvPr>
+          <p:cNvSpPr>
+            <a:spLocks xmlns:a="http://schemas.openxmlformats.org/drawingml/2006/main" noGrp="1"/>
+          </p:cNvSpPr>
+          <p:nvPr/>
+        </p:nvSpPr>
+        <p:spPr>
+          <a:xfrm xmlns:a="http://schemas.openxmlformats.org/drawingml/2006/main">
+            <a:off x="609600" y="685800"/>
+            <a:ext cx="10210800" cy="9525"/>
+          </a:xfrm>
+          <a:prstGeom xmlns:a="http://schemas.openxmlformats.org/drawingml/2006/main" prst="rect">
+            <a:avLst/>
+          </a:prstGeom>
+          <a:solidFill xmlns:a="http://schemas.openxmlformats.org/drawingml/2006/main">
+            <a:srgbClr val="78909C"/>
+          </a:solidFill>
+          <a:ln xmlns:a="http://schemas.openxmlformats.org/drawingml/2006/main" w="0">
+            <a:solidFill>
+              <a:srgbClr val="78909C"/>
+            </a:solidFill>
+            <a:prstDash val="solid"/>
+          </a:ln>
+        </p:spPr>
+      </p:sp>
+      <p:sp>
+        <p:nvSpPr>
+          <p:cNvPr id="5" name="title">
+            <a:extLst xmlns:a="http://schemas.openxmlformats.org/drawingml/2006/main">
+              <a:ext uri="{FF2B5EF4-FFF2-40B4-BE49-F238E27FC236}">
+                <a16:creationId xmlns:a16="http://schemas.microsoft.com/office/drawing/2014/main" id="{C5C597E5-B9D5-4C6F-8245-AA4004F77BFD}"/>
+              </a:ext>
+            </a:extLst>
+          </p:cNvPr>
+          <p:cNvSpPr>
+            <a:spLocks xmlns:a="http://schemas.openxmlformats.org/drawingml/2006/main" noGrp="1"/>
+          </p:cNvSpPr>
+          <p:nvPr/>
+        </p:nvSpPr>
+        <p:spPr>
+          <a:xfrm xmlns:a="http://schemas.openxmlformats.org/drawingml/2006/main">
+            <a:off x="609600" y="895350"/>
+            <a:ext cx="10210800" cy="666750"/>
+          </a:xfrm>
+          <a:prstGeom xmlns:a="http://schemas.openxmlformats.org/drawingml/2006/main" prst="rect">
+            <a:avLst/>
+          </a:prstGeom>
+          <a:noFill xmlns:a="http://schemas.openxmlformats.org/drawingml/2006/main"/>
+          <a:ln xmlns:a="http://schemas.openxmlformats.org/drawingml/2006/main" w="0">
+            <a:noFill/>
+            <a:prstDash val="solid"/>
+          </a:ln>
+        </p:spPr>
+        <p:txBody>
+          <a:bodyPr xmlns:a="http://schemas.openxmlformats.org/drawingml/2006/main" anchor="ctr"/>
+          <a:lstStyle xmlns:a="http://schemas.openxmlformats.org/drawingml/2006/main"/>
+          <a:p xmlns:a="http://schemas.openxmlformats.org/drawingml/2006/main">
+            <a:pPr algn="l">
+              <a:defRPr sz="2700" b="1">
+                <a:solidFill>
+                  <a:srgbClr val="F4F7FA"/>
+                </a:solidFill>
+              </a:defRPr>
+            </a:pPr>
+            <a:r>
+              <a:rPr sz="2700" b="1">
+                <a:solidFill>
+                  <a:srgbClr val="F4F7FA"/>
+                </a:solidFill>
+              </a:rPr>
+              <a:t>Hold the same lane and build BOOST for the pass</a:t>
+            </a:r>
+          </a:p>
+        </p:txBody>
+      </p:sp>
+      <p:sp>
+        <p:nvSpPr>
+          <p:cNvPr id="6" name="leader-car">
+            <a:extLst xmlns:a="http://schemas.openxmlformats.org/drawingml/2006/main">
+              <a:ext uri="{FF2B5EF4-FFF2-40B4-BE49-F238E27FC236}">
+                <a16:creationId xmlns:a16="http://schemas.microsoft.com/office/drawing/2014/main" id="{8041324B-5FAB-4E7D-98B2-CA5146913699}"/>
+              </a:ext>
+            </a:extLst>
+          </p:cNvPr>
+          <p:cNvSpPr>
+            <a:spLocks xmlns:a="http://schemas.openxmlformats.org/drawingml/2006/main" noGrp="1"/>
+          </p:cNvSpPr>
+          <p:nvPr/>
+        </p:nvSpPr>
+        <p:spPr>
+          <a:xfrm xmlns:a="http://schemas.openxmlformats.org/drawingml/2006/main">
+            <a:off x="6762750" y="1981200"/>
+            <a:ext cx="1428750" cy="514350"/>
+          </a:xfrm>
+          <a:prstGeom xmlns:a="http://schemas.openxmlformats.org/drawingml/2006/main" prst="rect">
+            <a:avLst/>
+          </a:prstGeom>
+          <a:noFill xmlns:a="http://schemas.openxmlformats.org/drawingml/2006/main"/>
+          <a:ln xmlns:a="http://schemas.openxmlformats.org/drawingml/2006/main" w="28575">
+            <a:solidFill>
+              <a:srgbClr val="4B7DFF"/>
+            </a:solidFill>
+            <a:prstDash val="solid"/>
+          </a:ln>
+        </p:spPr>
+      </p:sp>
+      <p:sp>
+        <p:nvSpPr>
+          <p:cNvPr id="7" name="trailer-car">
+            <a:extLst xmlns:a="http://schemas.openxmlformats.org/drawingml/2006/main">
+              <a:ext uri="{FF2B5EF4-FFF2-40B4-BE49-F238E27FC236}">
+                <a16:creationId xmlns:a16="http://schemas.microsoft.com/office/drawing/2014/main" id="{B7238FE3-8DF5-4F33-960E-88B3ACD7E31C}"/>
+              </a:ext>
+            </a:extLst>
+          </p:cNvPr>
+          <p:cNvSpPr>
+            <a:spLocks xmlns:a="http://schemas.openxmlformats.org/drawingml/2006/main" noGrp="1"/>
+          </p:cNvSpPr>
+          <p:nvPr/>
+        </p:nvSpPr>
+        <p:spPr>
+          <a:xfrm xmlns:a="http://schemas.openxmlformats.org/drawingml/2006/main">
+            <a:off x="3238500" y="1981200"/>
+            <a:ext cx="1428750" cy="514350"/>
+          </a:xfrm>
+          <a:prstGeom xmlns:a="http://schemas.openxmlformats.org/drawingml/2006/main" prst="rect">
+            <a:avLst/>
+          </a:prstGeom>
+          <a:noFill xmlns:a="http://schemas.openxmlformats.org/drawingml/2006/main"/>
+          <a:ln xmlns:a="http://schemas.openxmlformats.org/drawingml/2006/main" w="28575">
+            <a:solidFill>
+              <a:srgbClr val="FF506A"/>
+            </a:solidFill>
+            <a:prstDash val="solid"/>
+          </a:ln>
+        </p:spPr>
+      </p:sp>
+      <p:sp>
+        <p:nvSpPr>
+          <p:cNvPr id="8" name="leader-label">
+            <a:extLst xmlns:a="http://schemas.openxmlformats.org/drawingml/2006/main">
+              <a:ext uri="{FF2B5EF4-FFF2-40B4-BE49-F238E27FC236}">
+                <a16:creationId xmlns:a16="http://schemas.microsoft.com/office/drawing/2014/main" id="{17471E2C-97A7-474F-925F-28E5F6A71CCE}"/>
+              </a:ext>
+            </a:extLst>
+          </p:cNvPr>
+          <p:cNvSpPr>
+            <a:spLocks xmlns:a="http://schemas.openxmlformats.org/drawingml/2006/main" noGrp="1"/>
+          </p:cNvSpPr>
+          <p:nvPr/>
+        </p:nvSpPr>
+        <p:spPr>
+          <a:xfrm xmlns:a="http://schemas.openxmlformats.org/drawingml/2006/main">
+            <a:off x="6572250" y="2590800"/>
+            <a:ext cx="1809750" cy="323850"/>
+          </a:xfrm>
+          <a:prstGeom xmlns:a="http://schemas.openxmlformats.org/drawingml/2006/main" prst="rect">
+            <a:avLst/>
+          </a:prstGeom>
+          <a:noFill xmlns:a="http://schemas.openxmlformats.org/drawingml/2006/main"/>
+          <a:ln xmlns:a="http://schemas.openxmlformats.org/drawingml/2006/main" w="0">
+            <a:noFill/>
+            <a:prstDash val="solid"/>
+          </a:ln>
+        </p:spPr>
+        <p:txBody>
+          <a:bodyPr xmlns:a="http://schemas.openxmlformats.org/drawingml/2006/main" anchor="ctr"/>
+          <a:lstStyle xmlns:a="http://schemas.openxmlformats.org/drawingml/2006/main"/>
+          <a:p xmlns:a="http://schemas.openxmlformats.org/drawingml/2006/main">
+            <a:pPr algn="ctr">
+              <a:defRPr sz="1275" b="1">
+                <a:solidFill>
+                  <a:srgbClr val="4B7DFF"/>
+                </a:solidFill>
+              </a:defRPr>
+            </a:pPr>
+            <a:r>
+              <a:rPr sz="1275" b="1">
+                <a:solidFill>
+                  <a:srgbClr val="4B7DFF"/>
+                </a:solidFill>
+              </a:rPr>
+              <a:t>LEADER</a:t>
+            </a:r>
+          </a:p>
+        </p:txBody>
+      </p:sp>
+      <p:sp>
+        <p:nvSpPr>
+          <p:cNvPr id="9" name="trailer-label">
+            <a:extLst xmlns:a="http://schemas.openxmlformats.org/drawingml/2006/main">
+              <a:ext uri="{FF2B5EF4-FFF2-40B4-BE49-F238E27FC236}">
+                <a16:creationId xmlns:a16="http://schemas.microsoft.com/office/drawing/2014/main" id="{78B7A336-1042-482D-B63F-4CA73661D9FB}"/>
+              </a:ext>
+            </a:extLst>
+          </p:cNvPr>
+          <p:cNvSpPr>
+            <a:spLocks xmlns:a="http://schemas.openxmlformats.org/drawingml/2006/main" noGrp="1"/>
+          </p:cNvSpPr>
+          <p:nvPr/>
+        </p:nvSpPr>
+        <p:spPr>
+          <a:xfrm xmlns:a="http://schemas.openxmlformats.org/drawingml/2006/main">
+            <a:off x="3048000" y="2590800"/>
+            <a:ext cx="1809750" cy="323850"/>
+          </a:xfrm>
+          <a:prstGeom xmlns:a="http://schemas.openxmlformats.org/drawingml/2006/main" prst="rect">
+            <a:avLst/>
+          </a:prstGeom>
+          <a:noFill xmlns:a="http://schemas.openxmlformats.org/drawingml/2006/main"/>
+          <a:ln xmlns:a="http://schemas.openxmlformats.org/drawingml/2006/main" w="0">
+            <a:noFill/>
+            <a:prstDash val="solid"/>
+          </a:ln>
+        </p:spPr>
+        <p:txBody>
+          <a:bodyPr xmlns:a="http://schemas.openxmlformats.org/drawingml/2006/main" anchor="ctr"/>
+          <a:lstStyle xmlns:a="http://schemas.openxmlformats.org/drawingml/2006/main"/>
+          <a:p xmlns:a="http://schemas.openxmlformats.org/drawingml/2006/main">
+            <a:pPr algn="ctr">
+              <a:defRPr sz="1275" b="1">
+                <a:solidFill>
+                  <a:srgbClr val="FF506A"/>
+                </a:solidFill>
+              </a:defRPr>
+            </a:pPr>
+            <a:r>
+              <a:rPr sz="1275" b="1">
+                <a:solidFill>
+                  <a:srgbClr val="FF506A"/>
+                </a:solidFill>
+              </a:rPr>
+              <a:t>TRAILING</a:t>
+            </a:r>
+          </a:p>
+        </p:txBody>
+      </p:sp>
+      <p:sp>
+        <p:nvSpPr>
+          <p:cNvPr id="10" name="draft-line-1">
+            <a:extLst xmlns:a="http://schemas.openxmlformats.org/drawingml/2006/main">
+              <a:ext uri="{FF2B5EF4-FFF2-40B4-BE49-F238E27FC236}">
+                <a16:creationId xmlns:a16="http://schemas.microsoft.com/office/drawing/2014/main" id="{F1266D80-8C0F-43A6-ACB5-362656E206AC}"/>
+              </a:ext>
+            </a:extLst>
+          </p:cNvPr>
+          <p:cNvSpPr>
+            <a:spLocks xmlns:a="http://schemas.openxmlformats.org/drawingml/2006/main" noGrp="1"/>
+          </p:cNvSpPr>
+          <p:nvPr/>
+        </p:nvSpPr>
+        <p:spPr>
+          <a:xfrm xmlns:a="http://schemas.openxmlformats.org/drawingml/2006/main">
+            <a:off x="4810125" y="2114550"/>
+            <a:ext cx="1809750" cy="19050"/>
+          </a:xfrm>
+          <a:prstGeom xmlns:a="http://schemas.openxmlformats.org/drawingml/2006/main" prst="rect">
+            <a:avLst/>
+          </a:prstGeom>
+          <a:solidFill xmlns:a="http://schemas.openxmlformats.org/drawingml/2006/main">
+            <a:srgbClr val="00E6E6"/>
+          </a:solidFill>
+          <a:ln xmlns:a="http://schemas.openxmlformats.org/drawingml/2006/main" w="0">
+            <a:solidFill>
+              <a:srgbClr val="00E6E6"/>
+            </a:solidFill>
+            <a:prstDash val="solid"/>
+          </a:ln>
+        </p:spPr>
+      </p:sp>
+      <p:sp>
+        <p:nvSpPr>
+          <p:cNvPr id="11" name="draft-line-2">
+            <a:extLst xmlns:a="http://schemas.openxmlformats.org/drawingml/2006/main">
+              <a:ext uri="{FF2B5EF4-FFF2-40B4-BE49-F238E27FC236}">
+                <a16:creationId xmlns:a16="http://schemas.microsoft.com/office/drawing/2014/main" id="{CB73672E-1CC9-46B6-A7E9-A490649C7518}"/>
+              </a:ext>
+            </a:extLst>
+          </p:cNvPr>
+          <p:cNvSpPr>
+            <a:spLocks xmlns:a="http://schemas.openxmlformats.org/drawingml/2006/main" noGrp="1"/>
+          </p:cNvSpPr>
+          <p:nvPr/>
+        </p:nvSpPr>
+        <p:spPr>
+          <a:xfrm xmlns:a="http://schemas.openxmlformats.org/drawingml/2006/main">
+            <a:off x="5000625" y="2305050"/>
+            <a:ext cx="1428750" cy="19050"/>
+          </a:xfrm>
+          <a:prstGeom xmlns:a="http://schemas.openxmlformats.org/drawingml/2006/main" prst="rect">
+            <a:avLst/>
+          </a:prstGeom>
+          <a:solidFill xmlns:a="http://schemas.openxmlformats.org/drawingml/2006/main">
+            <a:srgbClr val="00E6E6"/>
+          </a:solidFill>
+          <a:ln xmlns:a="http://schemas.openxmlformats.org/drawingml/2006/main" w="0">
+            <a:solidFill>
+              <a:srgbClr val="00E6E6"/>
+            </a:solidFill>
+            <a:prstDash val="solid"/>
+          </a:ln>
+        </p:spPr>
+      </p:sp>
+      <p:sp>
+        <p:nvSpPr>
+          <p:cNvPr id="12" name="stage-01">
+            <a:extLst xmlns:a="http://schemas.openxmlformats.org/drawingml/2006/main">
+              <a:ext uri="{FF2B5EF4-FFF2-40B4-BE49-F238E27FC236}">
+                <a16:creationId xmlns:a16="http://schemas.microsoft.com/office/drawing/2014/main" id="{4BCD349E-3B05-4045-9CA5-8FB2AC943C22}"/>
+              </a:ext>
+            </a:extLst>
+          </p:cNvPr>
+          <p:cNvSpPr>
+            <a:spLocks xmlns:a="http://schemas.openxmlformats.org/drawingml/2006/main" noGrp="1"/>
+          </p:cNvSpPr>
+          <p:nvPr/>
+        </p:nvSpPr>
+        <p:spPr>
+          <a:xfrm xmlns:a="http://schemas.openxmlformats.org/drawingml/2006/main">
+            <a:off x="685800" y="3524250"/>
+            <a:ext cx="609600" cy="476250"/>
+          </a:xfrm>
+          <a:prstGeom xmlns:a="http://schemas.openxmlformats.org/drawingml/2006/main" prst="rect">
+            <a:avLst/>
+          </a:prstGeom>
+          <a:noFill xmlns:a="http://schemas.openxmlformats.org/drawingml/2006/main"/>
+          <a:ln xmlns:a="http://schemas.openxmlformats.org/drawingml/2006/main" w="0">
+            <a:noFill/>
+            <a:prstDash val="solid"/>
+          </a:ln>
+        </p:spPr>
+        <p:txBody>
+          <a:bodyPr xmlns:a="http://schemas.openxmlformats.org/drawingml/2006/main" anchor="ctr"/>
+          <a:lstStyle xmlns:a="http://schemas.openxmlformats.org/drawingml/2006/main"/>
+          <a:p xmlns:a="http://schemas.openxmlformats.org/drawingml/2006/main">
+            <a:pPr algn="l">
+              <a:defRPr sz="1650" b="1">
+                <a:solidFill>
+                  <a:srgbClr val="00E6E6"/>
+                </a:solidFill>
+              </a:defRPr>
+            </a:pPr>
+            <a:r>
+              <a:rPr sz="1650" b="1">
+                <a:solidFill>
+                  <a:srgbClr val="00E6E6"/>
+                </a:solidFill>
+              </a:rPr>
+              <a:t>01</a:t>
+            </a:r>
+          </a:p>
+        </p:txBody>
+      </p:sp>
+      <p:sp>
+        <p:nvSpPr>
+          <p:cNvPr id="13" name="stage-rule-01">
+            <a:extLst xmlns:a="http://schemas.openxmlformats.org/drawingml/2006/main">
+              <a:ext uri="{FF2B5EF4-FFF2-40B4-BE49-F238E27FC236}">
+                <a16:creationId xmlns:a16="http://schemas.microsoft.com/office/drawing/2014/main" id="{4810AF52-CBDA-4EFA-AB65-457CBEA1BAA3}"/>
+              </a:ext>
+            </a:extLst>
+          </p:cNvPr>
+          <p:cNvSpPr>
+            <a:spLocks xmlns:a="http://schemas.openxmlformats.org/drawingml/2006/main" noGrp="1"/>
+          </p:cNvSpPr>
+          <p:nvPr/>
+        </p:nvSpPr>
+        <p:spPr>
+          <a:xfrm xmlns:a="http://schemas.openxmlformats.org/drawingml/2006/main">
+            <a:off x="685800" y="4095750"/>
+            <a:ext cx="2857500" cy="28575"/>
+          </a:xfrm>
+          <a:prstGeom xmlns:a="http://schemas.openxmlformats.org/drawingml/2006/main" prst="rect">
+            <a:avLst/>
+          </a:prstGeom>
+          <a:solidFill xmlns:a="http://schemas.openxmlformats.org/drawingml/2006/main">
+            <a:srgbClr val="00E6E6"/>
+          </a:solidFill>
+          <a:ln xmlns:a="http://schemas.openxmlformats.org/drawingml/2006/main" w="0">
+            <a:solidFill>
+              <a:srgbClr val="00E6E6"/>
+            </a:solidFill>
+            <a:prstDash val="solid"/>
+          </a:ln>
+        </p:spPr>
+      </p:sp>
+      <p:sp>
+        <p:nvSpPr>
+          <p:cNvPr id="14" name="stage-head-01">
+            <a:extLst xmlns:a="http://schemas.openxmlformats.org/drawingml/2006/main">
+              <a:ext uri="{FF2B5EF4-FFF2-40B4-BE49-F238E27FC236}">
+                <a16:creationId xmlns:a16="http://schemas.microsoft.com/office/drawing/2014/main" id="{ABEB198F-7EBB-4950-82DB-40E013ECB363}"/>
+              </a:ext>
+            </a:extLst>
+          </p:cNvPr>
+          <p:cNvSpPr>
+            <a:spLocks xmlns:a="http://schemas.openxmlformats.org/drawingml/2006/main" noGrp="1"/>
+          </p:cNvSpPr>
+          <p:nvPr/>
+        </p:nvSpPr>
+        <p:spPr>
+          <a:xfrm xmlns:a="http://schemas.openxmlformats.org/drawingml/2006/main">
+            <a:off x="685800" y="4267200"/>
+            <a:ext cx="2857500" cy="457200"/>
+          </a:xfrm>
+          <a:prstGeom xmlns:a="http://schemas.openxmlformats.org/drawingml/2006/main" prst="rect">
+            <a:avLst/>
+          </a:prstGeom>
+          <a:noFill xmlns:a="http://schemas.openxmlformats.org/drawingml/2006/main"/>
+          <a:ln xmlns:a="http://schemas.openxmlformats.org/drawingml/2006/main" w="0">
+            <a:noFill/>
+            <a:prstDash val="solid"/>
+          </a:ln>
+        </p:spPr>
+        <p:txBody>
+          <a:bodyPr xmlns:a="http://schemas.openxmlformats.org/drawingml/2006/main" anchor="ctr"/>
+          <a:lstStyle xmlns:a="http://schemas.openxmlformats.org/drawingml/2006/main"/>
+          <a:p xmlns:a="http://schemas.openxmlformats.org/drawingml/2006/main">
+            <a:pPr algn="l">
+              <a:defRPr sz="1725" b="1">
+                <a:solidFill>
+                  <a:srgbClr val="00E6E6"/>
+                </a:solidFill>
+              </a:defRPr>
+            </a:pPr>
+            <a:r>
+              <a:rPr sz="1725" b="1">
+                <a:solidFill>
+                  <a:srgbClr val="00E6E6"/>
+                </a:solidFill>
+              </a:rPr>
+              <a:t>ALIGN</a:t>
+            </a:r>
+          </a:p>
+        </p:txBody>
+      </p:sp>
+      <p:sp>
+        <p:nvSpPr>
+          <p:cNvPr id="15" name="stage-body-01">
+            <a:extLst xmlns:a="http://schemas.openxmlformats.org/drawingml/2006/main">
+              <a:ext uri="{FF2B5EF4-FFF2-40B4-BE49-F238E27FC236}">
+                <a16:creationId xmlns:a16="http://schemas.microsoft.com/office/drawing/2014/main" id="{5AB1C7C7-5237-4AAB-B282-B44D4EE92B75}"/>
+              </a:ext>
+            </a:extLst>
+          </p:cNvPr>
+          <p:cNvSpPr>
+            <a:spLocks xmlns:a="http://schemas.openxmlformats.org/drawingml/2006/main" noGrp="1"/>
+          </p:cNvSpPr>
+          <p:nvPr/>
+        </p:nvSpPr>
+        <p:spPr>
+          <a:xfrm xmlns:a="http://schemas.openxmlformats.org/drawingml/2006/main">
+            <a:off x="685800" y="4857750"/>
+            <a:ext cx="2857500" cy="723900"/>
+          </a:xfrm>
+          <a:prstGeom xmlns:a="http://schemas.openxmlformats.org/drawingml/2006/main" prst="rect">
+            <a:avLst/>
+          </a:prstGeom>
+          <a:noFill xmlns:a="http://schemas.openxmlformats.org/drawingml/2006/main"/>
+          <a:ln xmlns:a="http://schemas.openxmlformats.org/drawingml/2006/main" w="0">
+            <a:noFill/>
+            <a:prstDash val="solid"/>
+          </a:ln>
+        </p:spPr>
+        <p:txBody>
+          <a:bodyPr xmlns:a="http://schemas.openxmlformats.org/drawingml/2006/main" anchor="ctr"/>
+          <a:lstStyle xmlns:a="http://schemas.openxmlformats.org/drawingml/2006/main"/>
+          <a:p xmlns:a="http://schemas.openxmlformats.org/drawingml/2006/main">
+            <a:pPr algn="l">
+              <a:defRPr sz="1425" b="0">
+                <a:solidFill>
+                  <a:srgbClr val="F4F7FA"/>
+                </a:solidFill>
+              </a:defRPr>
+            </a:pPr>
+            <a:r>
+              <a:rPr sz="1425" b="0">
+                <a:solidFill>
+                  <a:srgbClr val="F4F7FA"/>
+                </a:solidFill>
+              </a:rPr>
+              <a:t>Match the leader's lane smoothly</a:t>
+            </a:r>
+          </a:p>
+        </p:txBody>
+      </p:sp>
+      <p:sp>
+        <p:nvSpPr>
+          <p:cNvPr id="16" name="stage-02">
+            <a:extLst xmlns:a="http://schemas.openxmlformats.org/drawingml/2006/main">
+              <a:ext uri="{FF2B5EF4-FFF2-40B4-BE49-F238E27FC236}">
+                <a16:creationId xmlns:a16="http://schemas.microsoft.com/office/drawing/2014/main" id="{649F4A07-A53B-4C63-90B1-4DE444CD5B58}"/>
+              </a:ext>
+            </a:extLst>
+          </p:cNvPr>
+          <p:cNvSpPr>
+            <a:spLocks xmlns:a="http://schemas.openxmlformats.org/drawingml/2006/main" noGrp="1"/>
+          </p:cNvSpPr>
+          <p:nvPr/>
+        </p:nvSpPr>
+        <p:spPr>
+          <a:xfrm xmlns:a="http://schemas.openxmlformats.org/drawingml/2006/main">
+            <a:off x="4038600" y="3524250"/>
+            <a:ext cx="609600" cy="476250"/>
+          </a:xfrm>
+          <a:prstGeom xmlns:a="http://schemas.openxmlformats.org/drawingml/2006/main" prst="rect">
+            <a:avLst/>
+          </a:prstGeom>
+          <a:noFill xmlns:a="http://schemas.openxmlformats.org/drawingml/2006/main"/>
+          <a:ln xmlns:a="http://schemas.openxmlformats.org/drawingml/2006/main" w="0">
+            <a:noFill/>
+            <a:prstDash val="solid"/>
+          </a:ln>
+        </p:spPr>
+        <p:txBody>
+          <a:bodyPr xmlns:a="http://schemas.openxmlformats.org/drawingml/2006/main" anchor="ctr"/>
+          <a:lstStyle xmlns:a="http://schemas.openxmlformats.org/drawingml/2006/main"/>
+          <a:p xmlns:a="http://schemas.openxmlformats.org/drawingml/2006/main">
+            <a:pPr algn="l">
+              <a:defRPr sz="1650" b="1">
+                <a:solidFill>
+                  <a:srgbClr val="FFD34E"/>
+                </a:solidFill>
+              </a:defRPr>
+            </a:pPr>
+            <a:r>
+              <a:rPr sz="1650" b="1">
+                <a:solidFill>
+                  <a:srgbClr val="FFD34E"/>
+                </a:solidFill>
+              </a:rPr>
+              <a:t>02</a:t>
+            </a:r>
+          </a:p>
+        </p:txBody>
+      </p:sp>
+      <p:sp>
+        <p:nvSpPr>
+          <p:cNvPr id="17" name="stage-rule-02">
+            <a:extLst xmlns:a="http://schemas.openxmlformats.org/drawingml/2006/main">
+              <a:ext uri="{FF2B5EF4-FFF2-40B4-BE49-F238E27FC236}">
+                <a16:creationId xmlns:a16="http://schemas.microsoft.com/office/drawing/2014/main" id="{DA6B5E92-DD0A-4090-A42F-37EDAFD37449}"/>
+              </a:ext>
+            </a:extLst>
+          </p:cNvPr>
+          <p:cNvSpPr>
+            <a:spLocks xmlns:a="http://schemas.openxmlformats.org/drawingml/2006/main" noGrp="1"/>
+          </p:cNvSpPr>
+          <p:nvPr/>
+        </p:nvSpPr>
+        <p:spPr>
+          <a:xfrm xmlns:a="http://schemas.openxmlformats.org/drawingml/2006/main">
+            <a:off x="4038600" y="4095750"/>
+            <a:ext cx="2857500" cy="28575"/>
+          </a:xfrm>
+          <a:prstGeom xmlns:a="http://schemas.openxmlformats.org/drawingml/2006/main" prst="rect">
+            <a:avLst/>
+          </a:prstGeom>
+          <a:solidFill xmlns:a="http://schemas.openxmlformats.org/drawingml/2006/main">
+            <a:srgbClr val="FFD34E"/>
+          </a:solidFill>
+          <a:ln xmlns:a="http://schemas.openxmlformats.org/drawingml/2006/main" w="0">
+            <a:solidFill>
+              <a:srgbClr val="FFD34E"/>
+            </a:solidFill>
+            <a:prstDash val="solid"/>
+          </a:ln>
+        </p:spPr>
+      </p:sp>
+      <p:sp>
+        <p:nvSpPr>
+          <p:cNvPr id="18" name="stage-head-02">
+            <a:extLst xmlns:a="http://schemas.openxmlformats.org/drawingml/2006/main">
+              <a:ext uri="{FF2B5EF4-FFF2-40B4-BE49-F238E27FC236}">
+                <a16:creationId xmlns:a16="http://schemas.microsoft.com/office/drawing/2014/main" id="{D8C1CB17-115E-4E81-B842-F3A757273DC9}"/>
+              </a:ext>
+            </a:extLst>
+          </p:cNvPr>
+          <p:cNvSpPr>
+            <a:spLocks xmlns:a="http://schemas.openxmlformats.org/drawingml/2006/main" noGrp="1"/>
+          </p:cNvSpPr>
+          <p:nvPr/>
+        </p:nvSpPr>
+        <p:spPr>
+          <a:xfrm xmlns:a="http://schemas.openxmlformats.org/drawingml/2006/main">
+            <a:off x="4038600" y="4267200"/>
+            <a:ext cx="2857500" cy="457200"/>
+          </a:xfrm>
+          <a:prstGeom xmlns:a="http://schemas.openxmlformats.org/drawingml/2006/main" prst="rect">
+            <a:avLst/>
+          </a:prstGeom>
+          <a:noFill xmlns:a="http://schemas.openxmlformats.org/drawingml/2006/main"/>
+          <a:ln xmlns:a="http://schemas.openxmlformats.org/drawingml/2006/main" w="0">
+            <a:noFill/>
+            <a:prstDash val="solid"/>
+          </a:ln>
+        </p:spPr>
+        <p:txBody>
+          <a:bodyPr xmlns:a="http://schemas.openxmlformats.org/drawingml/2006/main" anchor="ctr"/>
+          <a:lstStyle xmlns:a="http://schemas.openxmlformats.org/drawingml/2006/main"/>
+          <a:p xmlns:a="http://schemas.openxmlformats.org/drawingml/2006/main">
+            <a:pPr algn="l">
+              <a:defRPr sz="1725" b="1">
+                <a:solidFill>
+                  <a:srgbClr val="FFD34E"/>
+                </a:solidFill>
+              </a:defRPr>
+            </a:pPr>
+            <a:r>
+              <a:rPr sz="1725" b="1">
+                <a:solidFill>
+                  <a:srgbClr val="FFD34E"/>
+                </a:solidFill>
+              </a:rPr>
+              <a:t>HOLD / 0.5 SEC</a:t>
+            </a:r>
+          </a:p>
+        </p:txBody>
+      </p:sp>
+      <p:sp>
+        <p:nvSpPr>
+          <p:cNvPr id="19" name="stage-body-02">
+            <a:extLst xmlns:a="http://schemas.openxmlformats.org/drawingml/2006/main">
+              <a:ext uri="{FF2B5EF4-FFF2-40B4-BE49-F238E27FC236}">
+                <a16:creationId xmlns:a16="http://schemas.microsoft.com/office/drawing/2014/main" id="{E8B875D4-D433-42A2-AA27-B0F3CE08F213}"/>
+              </a:ext>
+            </a:extLst>
+          </p:cNvPr>
+          <p:cNvSpPr>
+            <a:spLocks xmlns:a="http://schemas.openxmlformats.org/drawingml/2006/main" noGrp="1"/>
+          </p:cNvSpPr>
+          <p:nvPr/>
+        </p:nvSpPr>
+        <p:spPr>
+          <a:xfrm xmlns:a="http://schemas.openxmlformats.org/drawingml/2006/main">
+            <a:off x="4038600" y="4857750"/>
+            <a:ext cx="2857500" cy="723900"/>
+          </a:xfrm>
+          <a:prstGeom xmlns:a="http://schemas.openxmlformats.org/drawingml/2006/main" prst="rect">
+            <a:avLst/>
+          </a:prstGeom>
+          <a:noFill xmlns:a="http://schemas.openxmlformats.org/drawingml/2006/main"/>
+          <a:ln xmlns:a="http://schemas.openxmlformats.org/drawingml/2006/main" w="0">
+            <a:noFill/>
+            <a:prstDash val="solid"/>
+          </a:ln>
+        </p:spPr>
+        <p:txBody>
+          <a:bodyPr xmlns:a="http://schemas.openxmlformats.org/drawingml/2006/main" anchor="ctr"/>
+          <a:lstStyle xmlns:a="http://schemas.openxmlformats.org/drawingml/2006/main"/>
+          <a:p xmlns:a="http://schemas.openxmlformats.org/drawingml/2006/main">
+            <a:pPr algn="l">
+              <a:defRPr sz="1425" b="0">
+                <a:solidFill>
+                  <a:srgbClr val="F4F7FA"/>
+                </a:solidFill>
+              </a:defRPr>
+            </a:pPr>
+            <a:r>
+              <a:rPr sz="1425" b="0">
+                <a:solidFill>
+                  <a:srgbClr val="F4F7FA"/>
+                </a:solidFill>
+              </a:rPr>
+              <a:t>Maintain position for 10 fixed updates</a:t>
+            </a:r>
+          </a:p>
+        </p:txBody>
+      </p:sp>
+      <p:sp>
+        <p:nvSpPr>
+          <p:cNvPr id="20" name="stage-03">
+            <a:extLst xmlns:a="http://schemas.openxmlformats.org/drawingml/2006/main">
+              <a:ext uri="{FF2B5EF4-FFF2-40B4-BE49-F238E27FC236}">
+                <a16:creationId xmlns:a16="http://schemas.microsoft.com/office/drawing/2014/main" id="{0D3E4DC1-2B67-4782-AE57-31232B65C488}"/>
+              </a:ext>
+            </a:extLst>
+          </p:cNvPr>
+          <p:cNvSpPr>
+            <a:spLocks xmlns:a="http://schemas.openxmlformats.org/drawingml/2006/main" noGrp="1"/>
+          </p:cNvSpPr>
+          <p:nvPr/>
+        </p:nvSpPr>
+        <p:spPr>
+          <a:xfrm xmlns:a="http://schemas.openxmlformats.org/drawingml/2006/main">
+            <a:off x="7848600" y="3524250"/>
+            <a:ext cx="609600" cy="476250"/>
+          </a:xfrm>
+          <a:prstGeom xmlns:a="http://schemas.openxmlformats.org/drawingml/2006/main" prst="rect">
+            <a:avLst/>
+          </a:prstGeom>
+          <a:noFill xmlns:a="http://schemas.openxmlformats.org/drawingml/2006/main"/>
+          <a:ln xmlns:a="http://schemas.openxmlformats.org/drawingml/2006/main" w="0">
+            <a:noFill/>
+            <a:prstDash val="solid"/>
+          </a:ln>
+        </p:spPr>
+        <p:txBody>
+          <a:bodyPr xmlns:a="http://schemas.openxmlformats.org/drawingml/2006/main" anchor="ctr"/>
+          <a:lstStyle xmlns:a="http://schemas.openxmlformats.org/drawingml/2006/main"/>
+          <a:p xmlns:a="http://schemas.openxmlformats.org/drawingml/2006/main">
+            <a:pPr algn="l">
+              <a:defRPr sz="1650" b="1">
+                <a:solidFill>
+                  <a:srgbClr val="FF35D3"/>
+                </a:solidFill>
+              </a:defRPr>
+            </a:pPr>
+            <a:r>
+              <a:rPr sz="1650" b="1">
+                <a:solidFill>
+                  <a:srgbClr val="FF35D3"/>
+                </a:solidFill>
+              </a:rPr>
+              <a:t>03</a:t>
+            </a:r>
+          </a:p>
+        </p:txBody>
+      </p:sp>
+      <p:sp>
+        <p:nvSpPr>
+          <p:cNvPr id="21" name="stage-rule-03">
+            <a:extLst xmlns:a="http://schemas.openxmlformats.org/drawingml/2006/main">
+              <a:ext uri="{FF2B5EF4-FFF2-40B4-BE49-F238E27FC236}">
+                <a16:creationId xmlns:a16="http://schemas.microsoft.com/office/drawing/2014/main" id="{88265FB8-1421-4FE9-8010-29DCAE45DFE1}"/>
+              </a:ext>
+            </a:extLst>
+          </p:cNvPr>
+          <p:cNvSpPr>
+            <a:spLocks xmlns:a="http://schemas.openxmlformats.org/drawingml/2006/main" noGrp="1"/>
+          </p:cNvSpPr>
+          <p:nvPr/>
+        </p:nvSpPr>
+        <p:spPr>
+          <a:xfrm xmlns:a="http://schemas.openxmlformats.org/drawingml/2006/main">
+            <a:off x="7848600" y="4095750"/>
+            <a:ext cx="2857500" cy="28575"/>
+          </a:xfrm>
+          <a:prstGeom xmlns:a="http://schemas.openxmlformats.org/drawingml/2006/main" prst="rect">
+            <a:avLst/>
+          </a:prstGeom>
+          <a:solidFill xmlns:a="http://schemas.openxmlformats.org/drawingml/2006/main">
+            <a:srgbClr val="FF35D3"/>
+          </a:solidFill>
+          <a:ln xmlns:a="http://schemas.openxmlformats.org/drawingml/2006/main" w="0">
+            <a:solidFill>
+              <a:srgbClr val="FF35D3"/>
+            </a:solidFill>
+            <a:prstDash val="solid"/>
+          </a:ln>
+        </p:spPr>
+      </p:sp>
+      <p:sp>
+        <p:nvSpPr>
+          <p:cNvPr id="22" name="stage-head-03">
+            <a:extLst xmlns:a="http://schemas.openxmlformats.org/drawingml/2006/main">
+              <a:ext uri="{FF2B5EF4-FFF2-40B4-BE49-F238E27FC236}">
+                <a16:creationId xmlns:a16="http://schemas.microsoft.com/office/drawing/2014/main" id="{A27E066F-32C7-44C3-9614-A19258BA80DE}"/>
+              </a:ext>
+            </a:extLst>
+          </p:cNvPr>
+          <p:cNvSpPr>
+            <a:spLocks xmlns:a="http://schemas.openxmlformats.org/drawingml/2006/main" noGrp="1"/>
+          </p:cNvSpPr>
+          <p:nvPr/>
+        </p:nvSpPr>
+        <p:spPr>
+          <a:xfrm xmlns:a="http://schemas.openxmlformats.org/drawingml/2006/main">
+            <a:off x="7848600" y="4267200"/>
+            <a:ext cx="2857500" cy="457200"/>
+          </a:xfrm>
+          <a:prstGeom xmlns:a="http://schemas.openxmlformats.org/drawingml/2006/main" prst="rect">
+            <a:avLst/>
+          </a:prstGeom>
+          <a:noFill xmlns:a="http://schemas.openxmlformats.org/drawingml/2006/main"/>
+          <a:ln xmlns:a="http://schemas.openxmlformats.org/drawingml/2006/main" w="0">
+            <a:noFill/>
+            <a:prstDash val="solid"/>
+          </a:ln>
+        </p:spPr>
+        <p:txBody>
+          <a:bodyPr xmlns:a="http://schemas.openxmlformats.org/drawingml/2006/main" anchor="ctr"/>
+          <a:lstStyle xmlns:a="http://schemas.openxmlformats.org/drawingml/2006/main"/>
+          <a:p xmlns:a="http://schemas.openxmlformats.org/drawingml/2006/main">
+            <a:pPr algn="l">
+              <a:defRPr sz="1725" b="1">
+                <a:solidFill>
+                  <a:srgbClr val="FF35D3"/>
+                </a:solidFill>
+              </a:defRPr>
+            </a:pPr>
+            <a:r>
+              <a:rPr sz="1725" b="1">
+                <a:solidFill>
+                  <a:srgbClr val="FF35D3"/>
+                </a:solidFill>
+              </a:rPr>
+              <a:t>RECOVER BOOST</a:t>
+            </a:r>
+          </a:p>
+        </p:txBody>
+      </p:sp>
+      <p:sp>
+        <p:nvSpPr>
+          <p:cNvPr id="23" name="stage-body-03">
+            <a:extLst xmlns:a="http://schemas.openxmlformats.org/drawingml/2006/main">
+              <a:ext uri="{FF2B5EF4-FFF2-40B4-BE49-F238E27FC236}">
+                <a16:creationId xmlns:a16="http://schemas.microsoft.com/office/drawing/2014/main" id="{6BB23FC8-BDA1-4AAD-B84E-0E5B5AAE7298}"/>
+              </a:ext>
+            </a:extLst>
+          </p:cNvPr>
+          <p:cNvSpPr>
+            <a:spLocks xmlns:a="http://schemas.openxmlformats.org/drawingml/2006/main" noGrp="1"/>
+          </p:cNvSpPr>
+          <p:nvPr/>
+        </p:nvSpPr>
+        <p:spPr>
+          <a:xfrm xmlns:a="http://schemas.openxmlformats.org/drawingml/2006/main">
+            <a:off x="7848600" y="4857750"/>
+            <a:ext cx="2857500" cy="723900"/>
+          </a:xfrm>
+          <a:prstGeom xmlns:a="http://schemas.openxmlformats.org/drawingml/2006/main" prst="rect">
+            <a:avLst/>
+          </a:prstGeom>
+          <a:noFill xmlns:a="http://schemas.openxmlformats.org/drawingml/2006/main"/>
+          <a:ln xmlns:a="http://schemas.openxmlformats.org/drawingml/2006/main" w="0">
+            <a:noFill/>
+            <a:prstDash val="solid"/>
+          </a:ln>
+        </p:spPr>
+        <p:txBody>
+          <a:bodyPr xmlns:a="http://schemas.openxmlformats.org/drawingml/2006/main" anchor="ctr"/>
+          <a:lstStyle xmlns:a="http://schemas.openxmlformats.org/drawingml/2006/main"/>
+          <a:p xmlns:a="http://schemas.openxmlformats.org/drawingml/2006/main">
+            <a:pPr algn="l">
+              <a:defRPr sz="1425" b="0">
+                <a:solidFill>
+                  <a:srgbClr val="F4F7FA"/>
+                </a:solidFill>
+              </a:defRPr>
+            </a:pPr>
+            <a:r>
+              <a:rPr sz="1425" b="0">
+                <a:solidFill>
+                  <a:srgbClr val="F4F7FA"/>
+                </a:solidFill>
+              </a:rPr>
+              <a:t>Recover 8 per update; the car brightens</a:t>
+            </a:r>
+          </a:p>
+        </p:txBody>
+      </p:sp>
+      <p:sp>
+        <p:nvSpPr>
+          <p:cNvPr id="24" name="lower-rule">
+            <a:extLst xmlns:a="http://schemas.openxmlformats.org/drawingml/2006/main">
+              <a:ext uri="{FF2B5EF4-FFF2-40B4-BE49-F238E27FC236}">
+                <a16:creationId xmlns:a16="http://schemas.microsoft.com/office/drawing/2014/main" id="{040B85C7-D4A2-4F85-B2DE-D54EAFB66BA0}"/>
+              </a:ext>
+            </a:extLst>
+          </p:cNvPr>
+          <p:cNvSpPr>
+            <a:spLocks xmlns:a="http://schemas.openxmlformats.org/drawingml/2006/main" noGrp="1"/>
+          </p:cNvSpPr>
+          <p:nvPr/>
+        </p:nvSpPr>
+        <p:spPr>
+          <a:xfrm xmlns:a="http://schemas.openxmlformats.org/drawingml/2006/main">
+            <a:off x="685800" y="6057900"/>
+            <a:ext cx="10058400" cy="9525"/>
+          </a:xfrm>
+          <a:prstGeom xmlns:a="http://schemas.openxmlformats.org/drawingml/2006/main" prst="rect">
+            <a:avLst/>
+          </a:prstGeom>
+          <a:solidFill xmlns:a="http://schemas.openxmlformats.org/drawingml/2006/main">
+            <a:srgbClr val="78909C"/>
+          </a:solidFill>
+          <a:ln xmlns:a="http://schemas.openxmlformats.org/drawingml/2006/main" w="0">
+            <a:solidFill>
+              <a:srgbClr val="78909C"/>
+            </a:solidFill>
+            <a:prstDash val="solid"/>
+          </a:ln>
+        </p:spPr>
+      </p:sp>
+      <p:sp>
+        <p:nvSpPr>
+          <p:cNvPr id="25" name="near">
+            <a:extLst xmlns:a="http://schemas.openxmlformats.org/drawingml/2006/main">
+              <a:ext uri="{FF2B5EF4-FFF2-40B4-BE49-F238E27FC236}">
+                <a16:creationId xmlns:a16="http://schemas.microsoft.com/office/drawing/2014/main" id="{3282AC94-FAB6-4891-BA11-07D2D02EF8B6}"/>
+              </a:ext>
+            </a:extLst>
+          </p:cNvPr>
+          <p:cNvSpPr>
+            <a:spLocks xmlns:a="http://schemas.openxmlformats.org/drawingml/2006/main" noGrp="1"/>
+          </p:cNvSpPr>
+          <p:nvPr/>
+        </p:nvSpPr>
+        <p:spPr>
+          <a:xfrm xmlns:a="http://schemas.openxmlformats.org/drawingml/2006/main">
+            <a:off x="685800" y="6286500"/>
+            <a:ext cx="3048000" cy="361950"/>
+          </a:xfrm>
+          <a:prstGeom xmlns:a="http://schemas.openxmlformats.org/drawingml/2006/main" prst="rect">
+            <a:avLst/>
+          </a:prstGeom>
+          <a:noFill xmlns:a="http://schemas.openxmlformats.org/drawingml/2006/main"/>
+          <a:ln xmlns:a="http://schemas.openxmlformats.org/drawingml/2006/main" w="0">
+            <a:noFill/>
+            <a:prstDash val="solid"/>
+          </a:ln>
+        </p:spPr>
+        <p:txBody>
+          <a:bodyPr xmlns:a="http://schemas.openxmlformats.org/drawingml/2006/main" anchor="ctr"/>
+          <a:lstStyle xmlns:a="http://schemas.openxmlformats.org/drawingml/2006/main"/>
+          <a:p xmlns:a="http://schemas.openxmlformats.org/drawingml/2006/main">
+            <a:pPr algn="l">
+              <a:defRPr sz="1350" b="1">
+                <a:solidFill>
+                  <a:srgbClr val="00E6E6"/>
+                </a:solidFill>
+              </a:defRPr>
+            </a:pPr>
+            <a:r>
+              <a:rPr sz="1350" b="1">
+                <a:solidFill>
+                  <a:srgbClr val="00E6E6"/>
+                </a:solidFill>
+              </a:rPr>
+              <a:t>NEAR GAP  SLIPSTREAM</a:t>
+            </a:r>
+          </a:p>
+        </p:txBody>
+      </p:sp>
+      <p:sp>
+        <p:nvSpPr>
+          <p:cNvPr id="26" name="large">
+            <a:extLst xmlns:a="http://schemas.openxmlformats.org/drawingml/2006/main">
+              <a:ext uri="{FF2B5EF4-FFF2-40B4-BE49-F238E27FC236}">
+                <a16:creationId xmlns:a16="http://schemas.microsoft.com/office/drawing/2014/main" id="{E7A4C124-5D42-4E63-8B33-B21BCA626233}"/>
+              </a:ext>
+            </a:extLst>
+          </p:cNvPr>
+          <p:cNvSpPr>
+            <a:spLocks xmlns:a="http://schemas.openxmlformats.org/drawingml/2006/main" noGrp="1"/>
+          </p:cNvSpPr>
+          <p:nvPr/>
+        </p:nvSpPr>
+        <p:spPr>
+          <a:xfrm xmlns:a="http://schemas.openxmlformats.org/drawingml/2006/main">
+            <a:off x="4191000" y="6286500"/>
+            <a:ext cx="3429000" cy="361950"/>
+          </a:xfrm>
+          <a:prstGeom xmlns:a="http://schemas.openxmlformats.org/drawingml/2006/main" prst="rect">
+            <a:avLst/>
+          </a:prstGeom>
+          <a:noFill xmlns:a="http://schemas.openxmlformats.org/drawingml/2006/main"/>
+          <a:ln xmlns:a="http://schemas.openxmlformats.org/drawingml/2006/main" w="0">
+            <a:noFill/>
+            <a:prstDash val="solid"/>
+          </a:ln>
+        </p:spPr>
+        <p:txBody>
+          <a:bodyPr xmlns:a="http://schemas.openxmlformats.org/drawingml/2006/main" anchor="ctr"/>
+          <a:lstStyle xmlns:a="http://schemas.openxmlformats.org/drawingml/2006/main"/>
+          <a:p xmlns:a="http://schemas.openxmlformats.org/drawingml/2006/main">
+            <a:pPr algn="l">
+              <a:defRPr sz="1350" b="1">
+                <a:solidFill>
+                  <a:srgbClr val="FFD34E"/>
+                </a:solidFill>
+              </a:defRPr>
+            </a:pPr>
+            <a:r>
+              <a:rPr sz="1350" b="1">
+                <a:solidFill>
+                  <a:srgbClr val="FFD34E"/>
+                </a:solidFill>
+              </a:rPr>
+              <a:t>LARGE GAP  CATCH-UP RECOVERY</a:t>
+            </a:r>
+          </a:p>
+        </p:txBody>
+      </p:sp>
+      <p:sp>
+        <p:nvSpPr>
+          <p:cNvPr id="27" name="auto">
+            <a:extLst xmlns:a="http://schemas.openxmlformats.org/drawingml/2006/main">
+              <a:ext uri="{FF2B5EF4-FFF2-40B4-BE49-F238E27FC236}">
+                <a16:creationId xmlns:a16="http://schemas.microsoft.com/office/drawing/2014/main" id="{CCBC3F42-2653-4340-B180-7CEBA0E6D8EC}"/>
+              </a:ext>
+            </a:extLst>
+          </p:cNvPr>
+          <p:cNvSpPr>
+            <a:spLocks xmlns:a="http://schemas.openxmlformats.org/drawingml/2006/main" noGrp="1"/>
+          </p:cNvSpPr>
+          <p:nvPr/>
+        </p:nvSpPr>
+        <p:spPr>
+          <a:xfrm xmlns:a="http://schemas.openxmlformats.org/drawingml/2006/main">
+            <a:off x="7848600" y="6286500"/>
+            <a:ext cx="2895600" cy="361950"/>
+          </a:xfrm>
+          <a:prstGeom xmlns:a="http://schemas.openxmlformats.org/drawingml/2006/main" prst="rect">
+            <a:avLst/>
+          </a:prstGeom>
+          <a:noFill xmlns:a="http://schemas.openxmlformats.org/drawingml/2006/main"/>
+          <a:ln xmlns:a="http://schemas.openxmlformats.org/drawingml/2006/main" w="0">
+            <a:noFill/>
+            <a:prstDash val="solid"/>
+          </a:ln>
+        </p:spPr>
+        <p:txBody>
+          <a:bodyPr xmlns:a="http://schemas.openxmlformats.org/drawingml/2006/main" anchor="ctr"/>
+          <a:lstStyle xmlns:a="http://schemas.openxmlformats.org/drawingml/2006/main"/>
+          <a:p xmlns:a="http://schemas.openxmlformats.org/drawingml/2006/main">
+            <a:pPr algn="r">
+              <a:defRPr sz="1350" b="1">
+                <a:solidFill>
+                  <a:srgbClr val="FF35D3"/>
+                </a:solidFill>
+              </a:defRPr>
+            </a:pPr>
+            <a:r>
+              <a:rPr sz="1350" b="1">
+                <a:solidFill>
+                  <a:srgbClr val="FF35D3"/>
+                </a:solidFill>
+              </a:rPr>
+              <a:t>NO AUTOMATIC SPEED</a:t>
+            </a:r>
+          </a:p>
+        </p:txBody>
+      </p:sp>
+      <p:sp>
+        <p:nvSpPr>
+          <p:cNvPr id="28" name="tip">
+            <a:extLst xmlns:a="http://schemas.openxmlformats.org/drawingml/2006/main">
+              <a:ext uri="{FF2B5EF4-FFF2-40B4-BE49-F238E27FC236}">
+                <a16:creationId xmlns:a16="http://schemas.microsoft.com/office/drawing/2014/main" id="{86751F7E-FC21-44EA-83F2-8F4CEB947520}"/>
+              </a:ext>
+            </a:extLst>
+          </p:cNvPr>
+          <p:cNvSpPr>
+            <a:spLocks xmlns:a="http://schemas.openxmlformats.org/drawingml/2006/main" noGrp="1"/>
+          </p:cNvSpPr>
+          <p:nvPr/>
+        </p:nvSpPr>
+        <p:spPr>
+          <a:xfrm xmlns:a="http://schemas.openxmlformats.org/drawingml/2006/main">
+            <a:off x="1143000" y="6953250"/>
+            <a:ext cx="9144000" cy="514350"/>
+          </a:xfrm>
+          <a:prstGeom xmlns:a="http://schemas.openxmlformats.org/drawingml/2006/main" prst="rect">
+            <a:avLst/>
+          </a:prstGeom>
+          <a:noFill xmlns:a="http://schemas.openxmlformats.org/drawingml/2006/main"/>
+          <a:ln xmlns:a="http://schemas.openxmlformats.org/drawingml/2006/main" w="0">
+            <a:noFill/>
+            <a:prstDash val="solid"/>
+          </a:ln>
+        </p:spPr>
+        <p:txBody>
+          <a:bodyPr xmlns:a="http://schemas.openxmlformats.org/drawingml/2006/main" anchor="ctr"/>
+          <a:lstStyle xmlns:a="http://schemas.openxmlformats.org/drawingml/2006/main"/>
+          <a:p xmlns:a="http://schemas.openxmlformats.org/drawingml/2006/main">
+            <a:pPr algn="ctr">
+              <a:defRPr sz="1500" b="1">
+                <a:solidFill>
+                  <a:srgbClr val="F4F7FA"/>
+                </a:solidFill>
+              </a:defRPr>
+            </a:pPr>
+            <a:r>
+              <a:rPr sz="1500" b="1">
+                <a:solidFill>
+                  <a:srgbClr val="F4F7FA"/>
+                </a:solidFill>
+              </a:rPr>
+              <a:t>Wait for the bright-car signal, then spend BOOST to move out and pass. Contact range ends recovery.</a:t>
+            </a:r>
+          </a:p>
+        </p:txBody>
+      </p:sp>
+      <p:sp>
+        <p:nvSpPr>
+          <p:cNvPr id="29" name="footer-rule">
+            <a:extLst xmlns:a="http://schemas.openxmlformats.org/drawingml/2006/main">
+              <a:ext uri="{FF2B5EF4-FFF2-40B4-BE49-F238E27FC236}">
+                <a16:creationId xmlns:a16="http://schemas.microsoft.com/office/drawing/2014/main" id="{2E8DB086-C05D-42D6-A441-C972A6AC96AF}"/>
+              </a:ext>
+            </a:extLst>
+          </p:cNvPr>
+          <p:cNvSpPr>
+            <a:spLocks xmlns:a="http://schemas.openxmlformats.org/drawingml/2006/main" noGrp="1"/>
+          </p:cNvSpPr>
+          <p:nvPr/>
+        </p:nvSpPr>
+        <p:spPr>
+          <a:xfrm xmlns:a="http://schemas.openxmlformats.org/drawingml/2006/main">
+            <a:off x="609600" y="8020050"/>
+            <a:ext cx="10210800" cy="9525"/>
+          </a:xfrm>
+          <a:prstGeom xmlns:a="http://schemas.openxmlformats.org/drawingml/2006/main" prst="rect">
+            <a:avLst/>
+          </a:prstGeom>
+          <a:solidFill xmlns:a="http://schemas.openxmlformats.org/drawingml/2006/main">
+            <a:srgbClr val="78909C"/>
+          </a:solidFill>
+          <a:ln xmlns:a="http://schemas.openxmlformats.org/drawingml/2006/main" w="0">
+            <a:solidFill>
+              <a:srgbClr val="78909C"/>
+            </a:solidFill>
+            <a:prstDash val="solid"/>
+          </a:ln>
+        </p:spPr>
+      </p:sp>
+      <p:sp>
+        <p:nvSpPr>
+          <p:cNvPr id="30" name="footer-left">
+            <a:extLst xmlns:a="http://schemas.openxmlformats.org/drawingml/2006/main">
+              <a:ext uri="{FF2B5EF4-FFF2-40B4-BE49-F238E27FC236}">
+                <a16:creationId xmlns:a16="http://schemas.microsoft.com/office/drawing/2014/main" id="{B4BCDB45-6DE8-4EB5-8E1F-10E3963BA548}"/>
+              </a:ext>
+            </a:extLst>
+          </p:cNvPr>
+          <p:cNvSpPr>
+            <a:spLocks xmlns:a="http://schemas.openxmlformats.org/drawingml/2006/main" noGrp="1"/>
+          </p:cNvSpPr>
+          <p:nvPr/>
+        </p:nvSpPr>
+        <p:spPr>
+          <a:xfrm xmlns:a="http://schemas.openxmlformats.org/drawingml/2006/main">
+            <a:off x="609600" y="8096250"/>
+            <a:ext cx="2857500" cy="285750"/>
+          </a:xfrm>
+          <a:prstGeom xmlns:a="http://schemas.openxmlformats.org/drawingml/2006/main" prst="rect">
+            <a:avLst/>
+          </a:prstGeom>
+          <a:noFill xmlns:a="http://schemas.openxmlformats.org/drawingml/2006/main"/>
+          <a:ln xmlns:a="http://schemas.openxmlformats.org/drawingml/2006/main" w="0">
+            <a:noFill/>
+            <a:prstDash val="solid"/>
+          </a:ln>
+        </p:spPr>
+        <p:txBody>
+          <a:bodyPr xmlns:a="http://schemas.openxmlformats.org/drawingml/2006/main" anchor="ctr"/>
+          <a:lstStyle xmlns:a="http://schemas.openxmlformats.org/drawingml/2006/main"/>
+          <a:p xmlns:a="http://schemas.openxmlformats.org/drawingml/2006/main">
+            <a:pPr algn="l">
+              <a:defRPr sz="975" b="1">
+                <a:solidFill>
+                  <a:srgbClr val="78909C"/>
+                </a:solidFill>
+              </a:defRPr>
+            </a:pPr>
+            <a:r>
+              <a:rPr sz="975" b="1">
+                <a:solidFill>
+                  <a:srgbClr val="78909C"/>
+                </a:solidFill>
+              </a:rPr>
+              <a:t>WIRE DRIFT RACERS</a:t>
+            </a:r>
+          </a:p>
+        </p:txBody>
+      </p:sp>
+      <p:sp>
+        <p:nvSpPr>
+          <p:cNvPr id="31" name="footer-right">
+            <a:extLst xmlns:a="http://schemas.openxmlformats.org/drawingml/2006/main">
+              <a:ext uri="{FF2B5EF4-FFF2-40B4-BE49-F238E27FC236}">
+                <a16:creationId xmlns:a16="http://schemas.microsoft.com/office/drawing/2014/main" id="{6F2FC166-1FE6-4510-BD63-2CB28097FF9A}"/>
+              </a:ext>
+            </a:extLst>
+          </p:cNvPr>
+          <p:cNvSpPr>
+            <a:spLocks xmlns:a="http://schemas.openxmlformats.org/drawingml/2006/main" noGrp="1"/>
+          </p:cNvSpPr>
+          <p:nvPr/>
+        </p:nvSpPr>
+        <p:spPr>
+          <a:xfrm xmlns:a="http://schemas.openxmlformats.org/drawingml/2006/main">
+            <a:off x="7810500" y="8096250"/>
+            <a:ext cx="3009900" cy="285750"/>
+          </a:xfrm>
+          <a:prstGeom xmlns:a="http://schemas.openxmlformats.org/drawingml/2006/main" prst="rect">
+            <a:avLst/>
+          </a:prstGeom>
+          <a:noFill xmlns:a="http://schemas.openxmlformats.org/drawingml/2006/main"/>
+          <a:ln xmlns:a="http://schemas.openxmlformats.org/drawingml/2006/main" w="0">
+            <a:noFill/>
+            <a:prstDash val="solid"/>
+          </a:ln>
+        </p:spPr>
+        <p:txBody>
+          <a:bodyPr xmlns:a="http://schemas.openxmlformats.org/drawingml/2006/main" anchor="ctr"/>
+          <a:lstStyle xmlns:a="http://schemas.openxmlformats.org/drawingml/2006/main"/>
+          <a:p xmlns:a="http://schemas.openxmlformats.org/drawingml/2006/main">
+            <a:pPr algn="r">
+              <a:defRPr sz="975" b="0">
+                <a:solidFill>
+                  <a:srgbClr val="78909C"/>
+                </a:solidFill>
+              </a:defRPr>
+            </a:pPr>
+            <a:r>
+              <a:rPr sz="975" b="0">
+                <a:solidFill>
+                  <a:srgbClr val="78909C"/>
+                </a:solidFill>
+              </a:rPr>
+              <a:t>X68000 / 3 LAPS / 2 CARS</a:t>
+            </a:r>
+          </a:p>
+        </p:txBody>
+      </p:sp>
+    </p:spTree>
+    <p:extLst>
+      <p:ext uri="{BB962C8B-B14F-4D97-AF65-F5344CB8AC3E}">
+        <p14:creationId xmlns:p14="http://schemas.microsoft.com/office/powerpoint/2010/main" val="313376631"/>
+      </p:ext>
+    </p:extLst>
+  </p:cSld>
+</p:sld>
+</file>
+
+<file path=ppt/slides/slide17.xml><?xml version="1.0" encoding="utf-8"?>
+<p:sld xmlns:p="http://schemas.openxmlformats.org/presentationml/2006/main">
+  <p:cSld>
     <p:bg>
       <p:bgPr>
         <a:solidFill xmlns:a="http://schemas.openxmlformats.org/drawingml/2006/main">
@@ -16531,6 +18045,7 @@
           <a:lstStyle xmlns:a="http://schemas.openxmlformats.org/drawingml/2006/main"/>
           <a:p xmlns:a="http://schemas.openxmlformats.org/drawingml/2006/main">
             <a:pPr algn="l">
+              <a:buNone/>
               <a:defRPr sz="1350" b="1">
                 <a:solidFill>
                   <a:srgbClr val="00E6E6"/>
@@ -16614,6 +18129,7 @@
           <a:lstStyle xmlns:a="http://schemas.openxmlformats.org/drawingml/2006/main"/>
           <a:p xmlns:a="http://schemas.openxmlformats.org/drawingml/2006/main">
             <a:pPr algn="l">
+              <a:buNone/>
               <a:defRPr sz="2700" b="1">
                 <a:solidFill>
                   <a:srgbClr val="F4F7FA"/>
@@ -16792,6 +18308,7 @@
           <a:lstStyle xmlns:a="http://schemas.openxmlformats.org/drawingml/2006/main"/>
           <a:p xmlns:a="http://schemas.openxmlformats.org/drawingml/2006/main">
             <a:pPr algn="ctr">
+              <a:buNone/>
               <a:defRPr sz="2400" b="1">
                 <a:solidFill>
                   <a:srgbClr val="00E6E6"/>
@@ -16842,6 +18359,7 @@
           <a:lstStyle xmlns:a="http://schemas.openxmlformats.org/drawingml/2006/main"/>
           <a:p xmlns:a="http://schemas.openxmlformats.org/drawingml/2006/main">
             <a:pPr algn="ctr">
+              <a:buNone/>
               <a:defRPr sz="1500" b="0">
                 <a:solidFill>
                   <a:srgbClr val="F4F7FA"/>
@@ -16859,6 +18377,7 @@
           </a:p>
           <a:p xmlns:a="http://schemas.openxmlformats.org/drawingml/2006/main">
             <a:pPr algn="ctr">
+              <a:buNone/>
               <a:defRPr sz="1500" b="0">
                 <a:solidFill>
                   <a:srgbClr val="F4F7FA"/>
@@ -16971,6 +18490,7 @@
           <a:lstStyle xmlns:a="http://schemas.openxmlformats.org/drawingml/2006/main"/>
           <a:p xmlns:a="http://schemas.openxmlformats.org/drawingml/2006/main">
             <a:pPr algn="ctr">
+              <a:buNone/>
               <a:defRPr sz="2400" b="1">
                 <a:solidFill>
                   <a:srgbClr val="F4F7FA"/>
@@ -17021,6 +18541,7 @@
           <a:lstStyle xmlns:a="http://schemas.openxmlformats.org/drawingml/2006/main"/>
           <a:p xmlns:a="http://schemas.openxmlformats.org/drawingml/2006/main">
             <a:pPr algn="ctr">
+              <a:buNone/>
               <a:defRPr sz="1500" b="0">
                 <a:solidFill>
                   <a:srgbClr val="F4F7FA"/>
@@ -17038,6 +18559,7 @@
           </a:p>
           <a:p xmlns:a="http://schemas.openxmlformats.org/drawingml/2006/main">
             <a:pPr algn="ctr">
+              <a:buNone/>
               <a:defRPr sz="1500" b="0">
                 <a:solidFill>
                   <a:srgbClr val="F4F7FA"/>
@@ -17150,6 +18672,7 @@
           <a:lstStyle xmlns:a="http://schemas.openxmlformats.org/drawingml/2006/main"/>
           <a:p xmlns:a="http://schemas.openxmlformats.org/drawingml/2006/main">
             <a:pPr algn="ctr">
+              <a:buNone/>
               <a:defRPr sz="2400" b="1">
                 <a:solidFill>
                   <a:srgbClr val="FF35D3"/>
@@ -17200,6 +18723,7 @@
           <a:lstStyle xmlns:a="http://schemas.openxmlformats.org/drawingml/2006/main"/>
           <a:p xmlns:a="http://schemas.openxmlformats.org/drawingml/2006/main">
             <a:pPr algn="ctr">
+              <a:buNone/>
               <a:defRPr sz="1500" b="0">
                 <a:solidFill>
                   <a:srgbClr val="F4F7FA"/>
@@ -17217,6 +18741,7 @@
           </a:p>
           <a:p xmlns:a="http://schemas.openxmlformats.org/drawingml/2006/main">
             <a:pPr algn="ctr">
+              <a:buNone/>
               <a:defRPr sz="1500" b="0">
                 <a:solidFill>
                   <a:srgbClr val="F4F7FA"/>
@@ -17300,6 +18825,7 @@
           <a:lstStyle xmlns:a="http://schemas.openxmlformats.org/drawingml/2006/main"/>
           <a:p xmlns:a="http://schemas.openxmlformats.org/drawingml/2006/main">
             <a:pPr algn="ctr">
+              <a:buNone/>
               <a:defRPr sz="1500" b="1">
                 <a:solidFill>
                   <a:srgbClr val="F4F7FA"/>
@@ -17350,6 +18876,7 @@
           <a:lstStyle xmlns:a="http://schemas.openxmlformats.org/drawingml/2006/main"/>
           <a:p xmlns:a="http://schemas.openxmlformats.org/drawingml/2006/main">
             <a:pPr algn="ctr">
+              <a:buNone/>
               <a:defRPr sz="1275" b="0">
                 <a:solidFill>
                   <a:srgbClr val="78909C"/>
@@ -17362,7 +18889,15 @@
                   <a:srgbClr val="78909C"/>
                 </a:solidFill>
               </a:rPr>
-              <a:t>ALL COURSES: 3 LAPS / SAME PHYSICS / ACTIVE GATE / CATCH-UP BOOST</a:t>
+              <a:t>ALL COURSES: 3 LAPS / SAME PHYSICS / ACTIVE GATE / </a:t>
+            </a:r>
+            <a:r>
+              <a:rPr sz="1275" b="0">
+                <a:solidFill>
+                  <a:srgbClr val="78909C"/>
+                </a:solidFill>
+              </a:rPr>
+              <a:t>SLIPSTREAM + CATCH-UP</a:t>
             </a:r>
           </a:p>
         </p:txBody>
@@ -17433,6 +18968,7 @@
           <a:lstStyle xmlns:a="http://schemas.openxmlformats.org/drawingml/2006/main"/>
           <a:p xmlns:a="http://schemas.openxmlformats.org/drawingml/2006/main">
             <a:pPr algn="l">
+              <a:buNone/>
               <a:defRPr sz="975" b="1">
                 <a:solidFill>
                   <a:srgbClr val="78909C"/>
@@ -17483,6 +19019,7 @@
           <a:lstStyle xmlns:a="http://schemas.openxmlformats.org/drawingml/2006/main"/>
           <a:p xmlns:a="http://schemas.openxmlformats.org/drawingml/2006/main">
             <a:pPr algn="r">
+              <a:buNone/>
               <a:defRPr sz="975" b="0">
                 <a:solidFill>
                   <a:srgbClr val="78909C"/>

</xml_diff>

<commit_message>
Slipstream tuning and projection refactor
Adjust slipstream activation and feedback: broaden trailing gap to 1/8 lap, increase offset limit to 48, reduce lock-on from 10->6 frames (~0.3s), and raise recovery from 8->12 per update. Add DRAFT HUD state, blinking SLIP, rear-edge highlight rendering, COLOR_SLIP, and prevent catch-up boost from stacking with slipstream. Refactor projection pipeline: Car::project and prepare_render accept projection params; mkintro.py now fits intro->race views, produces race projections and kRaceTracks, and validates fitted frames. Update manuals, progress notes, assets, and rebuild distribution.
</commit_message>
<xml_diff>
--- a/doc/manual-en.pptx
+++ b/doc/manual-en.pptx
@@ -2,29 +2,29 @@
 <file path=ppt/presentation.xml><?xml version="1.0" encoding="utf-8"?>
 <p:presentation xmlns:p="http://schemas.openxmlformats.org/presentationml/2006/main">
   <p:sldMasterIdLst>
-    <p:sldMasterId xmlns:r="http://schemas.openxmlformats.org/officeDocument/2006/relationships" id="2147483648" r:id="R37bdc853ecf042e3"/>
+    <p:sldMasterId xmlns:r="http://schemas.openxmlformats.org/officeDocument/2006/relationships" id="2147483648" r:id="R5d117c146cce47dc"/>
   </p:sldMasterIdLst>
   <p:notesMasterIdLst>
-    <p:notesMasterId xmlns:r="http://schemas.openxmlformats.org/officeDocument/2006/relationships" r:id="Rb988c1c758884836"/>
+    <p:notesMasterId xmlns:r="http://schemas.openxmlformats.org/officeDocument/2006/relationships" r:id="R95414a97143045a6"/>
   </p:notesMasterIdLst>
   <p:sldIdLst>
-    <p:sldId xmlns:r="http://schemas.openxmlformats.org/officeDocument/2006/relationships" id="256" r:id="R9df5cd7233304a0a"/>
-    <p:sldId xmlns:r="http://schemas.openxmlformats.org/officeDocument/2006/relationships" id="257" r:id="R15be0a8a703f43b9"/>
-    <p:sldId xmlns:r="http://schemas.openxmlformats.org/officeDocument/2006/relationships" id="258" r:id="Rdabf6619d4964a22"/>
-    <p:sldId xmlns:r="http://schemas.openxmlformats.org/officeDocument/2006/relationships" id="259" r:id="R22d3a13c32fe436b"/>
-    <p:sldId xmlns:r="http://schemas.openxmlformats.org/officeDocument/2006/relationships" id="260" r:id="R0436017529b64e11"/>
-    <p:sldId xmlns:r="http://schemas.openxmlformats.org/officeDocument/2006/relationships" id="261" r:id="R6825ecddc2a744ad"/>
-    <p:sldId xmlns:r="http://schemas.openxmlformats.org/officeDocument/2006/relationships" id="262" r:id="R1147ceedc1d04ddc"/>
-    <p:sldId xmlns:r="http://schemas.openxmlformats.org/officeDocument/2006/relationships" id="263" r:id="R29dd3ec2e0a64665"/>
-    <p:sldId xmlns:r="http://schemas.openxmlformats.org/officeDocument/2006/relationships" id="264" r:id="R83b626e4209f4478"/>
-    <p:sldId xmlns:r="http://schemas.openxmlformats.org/officeDocument/2006/relationships" id="265" r:id="R5c83850916fe45ab"/>
-    <p:sldId xmlns:r="http://schemas.openxmlformats.org/officeDocument/2006/relationships" id="266" r:id="R0ec3f0e66f4040a4"/>
-    <p:sldId xmlns:r="http://schemas.openxmlformats.org/officeDocument/2006/relationships" id="267" r:id="Rc1bb467c51dc4fcc"/>
-    <p:sldId xmlns:r="http://schemas.openxmlformats.org/officeDocument/2006/relationships" id="268" r:id="R5f94d270969e4e4f"/>
-    <p:sldId xmlns:r="http://schemas.openxmlformats.org/officeDocument/2006/relationships" id="269" r:id="Rabd89df43d3e4073"/>
-    <p:sldId xmlns:r="http://schemas.openxmlformats.org/officeDocument/2006/relationships" id="270" r:id="R6faf9c70c1e24efa"/>
-    <p:sldId xmlns:r="http://schemas.openxmlformats.org/officeDocument/2006/relationships" id="271" r:id="R70b75395420c4495"/>
-    <p:sldId xmlns:r="http://schemas.openxmlformats.org/officeDocument/2006/relationships" id="272" r:id="Raf652a4f2dbd422f"/>
+    <p:sldId xmlns:r="http://schemas.openxmlformats.org/officeDocument/2006/relationships" id="256" r:id="R086daf6cb1064afd"/>
+    <p:sldId xmlns:r="http://schemas.openxmlformats.org/officeDocument/2006/relationships" id="257" r:id="R2f1b0f97cb474dfc"/>
+    <p:sldId xmlns:r="http://schemas.openxmlformats.org/officeDocument/2006/relationships" id="258" r:id="Rd5f55d8890bb46d7"/>
+    <p:sldId xmlns:r="http://schemas.openxmlformats.org/officeDocument/2006/relationships" id="259" r:id="R54120df537e24d56"/>
+    <p:sldId xmlns:r="http://schemas.openxmlformats.org/officeDocument/2006/relationships" id="260" r:id="Ra10989eb920a43d5"/>
+    <p:sldId xmlns:r="http://schemas.openxmlformats.org/officeDocument/2006/relationships" id="261" r:id="Rd740034af930479b"/>
+    <p:sldId xmlns:r="http://schemas.openxmlformats.org/officeDocument/2006/relationships" id="262" r:id="R65898f9fba8e48ac"/>
+    <p:sldId xmlns:r="http://schemas.openxmlformats.org/officeDocument/2006/relationships" id="263" r:id="R0da4e996257a4e4d"/>
+    <p:sldId xmlns:r="http://schemas.openxmlformats.org/officeDocument/2006/relationships" id="264" r:id="R2481b3f0d7b24a9c"/>
+    <p:sldId xmlns:r="http://schemas.openxmlformats.org/officeDocument/2006/relationships" id="265" r:id="Rd0f0c3d8796542da"/>
+    <p:sldId xmlns:r="http://schemas.openxmlformats.org/officeDocument/2006/relationships" id="266" r:id="R3ffe652865644f7c"/>
+    <p:sldId xmlns:r="http://schemas.openxmlformats.org/officeDocument/2006/relationships" id="267" r:id="Rd8b57125f4f44de5"/>
+    <p:sldId xmlns:r="http://schemas.openxmlformats.org/officeDocument/2006/relationships" id="268" r:id="R625fd9013459409a"/>
+    <p:sldId xmlns:r="http://schemas.openxmlformats.org/officeDocument/2006/relationships" id="269" r:id="R9fc2e7e308904aa3"/>
+    <p:sldId xmlns:r="http://schemas.openxmlformats.org/officeDocument/2006/relationships" id="270" r:id="R93085856b4fb4b4f"/>
+    <p:sldId xmlns:r="http://schemas.openxmlformats.org/officeDocument/2006/relationships" id="271" r:id="Rac3c541a96224d62"/>
+    <p:sldId xmlns:r="http://schemas.openxmlformats.org/officeDocument/2006/relationships" id="272" r:id="Rc0c2f79677a44d1e"/>
   </p:sldIdLst>
   <p:sldSz cx="11430000" cy="8572500"/>
   <p:notesSz cx="6858000" cy="9144000"/>
@@ -1578,7 +1578,7 @@
   </p:cSld>
   <p:clrMap bg1="lt1" tx1="dk1" bg2="lt2" tx2="dk2" accent1="accent1" accent2="accent2" accent3="accent3" accent4="accent4" accent5="accent5" accent6="accent6" hlink="hlink" folHlink="folHlink"/>
   <p:sldLayoutIdLst>
-    <p:sldLayoutId xmlns:r="http://schemas.openxmlformats.org/officeDocument/2006/relationships" id="2147483649" r:id="Rbcddfbd9f9534d29"/>
+    <p:sldLayoutId xmlns:r="http://schemas.openxmlformats.org/officeDocument/2006/relationships" id="2147483649" r:id="R4d2a039fe0c744d4"/>
   </p:sldLayoutIdLst>
   <p:txStyles>
     <p:titleStyle>
@@ -4151,7 +4151,7 @@
                   <a:srgbClr val="F3FBFF"/>
                 </a:solidFill>
               </a:rPr>
-              <a:t>At close range, hold the leader's lane for 0.5 sec to recover BOOST. Large gaps use catch-up recovery. Neither adds automatic speed.</a:t>
+              <a:t>At close range, hold the leader's lane for 0.3 sec: DRAFT becomes SLIP and recovers 12 per update. It does not add automatic speed.</a:t>
             </a:r>
           </a:p>
         </p:txBody>
@@ -4469,6 +4469,7 @@
           <a:lstStyle xmlns:a="http://schemas.openxmlformats.org/drawingml/2006/main"/>
           <a:p xmlns:a="http://schemas.openxmlformats.org/drawingml/2006/main">
             <a:pPr algn="l">
+              <a:buNone/>
               <a:defRPr sz="1725" b="1">
                 <a:solidFill>
                   <a:srgbClr val="00E6E6"/>
@@ -11077,6 +11078,7 @@
           <a:lstStyle xmlns:a="http://schemas.openxmlformats.org/drawingml/2006/main"/>
           <a:p xmlns:a="http://schemas.openxmlformats.org/drawingml/2006/main">
             <a:pPr algn="l">
+              <a:buNone/>
               <a:defRPr sz="1350" b="1">
                 <a:solidFill>
                   <a:srgbClr val="FF35D3"/>
@@ -11160,6 +11162,7 @@
           <a:lstStyle xmlns:a="http://schemas.openxmlformats.org/drawingml/2006/main"/>
           <a:p xmlns:a="http://schemas.openxmlformats.org/drawingml/2006/main">
             <a:pPr algn="l">
+              <a:buNone/>
               <a:defRPr sz="2700" b="1">
                 <a:solidFill>
                   <a:srgbClr val="F4F7FA"/>
@@ -11272,6 +11275,7 @@
           <a:lstStyle xmlns:a="http://schemas.openxmlformats.org/drawingml/2006/main"/>
           <a:p xmlns:a="http://schemas.openxmlformats.org/drawingml/2006/main">
             <a:pPr algn="ctr">
+              <a:buNone/>
               <a:defRPr sz="1275" b="1">
                 <a:solidFill>
                   <a:srgbClr val="4B7DFF"/>
@@ -11322,6 +11326,7 @@
           <a:lstStyle xmlns:a="http://schemas.openxmlformats.org/drawingml/2006/main"/>
           <a:p xmlns:a="http://schemas.openxmlformats.org/drawingml/2006/main">
             <a:pPr algn="ctr">
+              <a:buNone/>
               <a:defRPr sz="1275" b="1">
                 <a:solidFill>
                   <a:srgbClr val="FF506A"/>
@@ -11438,6 +11443,7 @@
           <a:lstStyle xmlns:a="http://schemas.openxmlformats.org/drawingml/2006/main"/>
           <a:p xmlns:a="http://schemas.openxmlformats.org/drawingml/2006/main">
             <a:pPr algn="l">
+              <a:buNone/>
               <a:defRPr sz="1650" b="1">
                 <a:solidFill>
                   <a:srgbClr val="00E6E6"/>
@@ -11521,6 +11527,7 @@
           <a:lstStyle xmlns:a="http://schemas.openxmlformats.org/drawingml/2006/main"/>
           <a:p xmlns:a="http://schemas.openxmlformats.org/drawingml/2006/main">
             <a:pPr algn="l">
+              <a:buNone/>
               <a:defRPr sz="1725" b="1">
                 <a:solidFill>
                   <a:srgbClr val="00E6E6"/>
@@ -11571,6 +11578,7 @@
           <a:lstStyle xmlns:a="http://schemas.openxmlformats.org/drawingml/2006/main"/>
           <a:p xmlns:a="http://schemas.openxmlformats.org/drawingml/2006/main">
             <a:pPr algn="l">
+              <a:buNone/>
               <a:defRPr sz="1425" b="0">
                 <a:solidFill>
                   <a:srgbClr val="F4F7FA"/>
@@ -11621,6 +11629,7 @@
           <a:lstStyle xmlns:a="http://schemas.openxmlformats.org/drawingml/2006/main"/>
           <a:p xmlns:a="http://schemas.openxmlformats.org/drawingml/2006/main">
             <a:pPr algn="l">
+              <a:buNone/>
               <a:defRPr sz="1650" b="1">
                 <a:solidFill>
                   <a:srgbClr val="FFD34E"/>
@@ -11704,6 +11713,7 @@
           <a:lstStyle xmlns:a="http://schemas.openxmlformats.org/drawingml/2006/main"/>
           <a:p xmlns:a="http://schemas.openxmlformats.org/drawingml/2006/main">
             <a:pPr algn="l">
+              <a:buNone/>
               <a:defRPr sz="1725" b="1">
                 <a:solidFill>
                   <a:srgbClr val="FFD34E"/>
@@ -11716,7 +11726,7 @@
                   <a:srgbClr val="FFD34E"/>
                 </a:solidFill>
               </a:rPr>
-              <a:t>HOLD / 0.5 SEC</a:t>
+              <a:t>HOLD / 0.3 SEC</a:t>
             </a:r>
           </a:p>
         </p:txBody>
@@ -11754,6 +11764,7 @@
           <a:lstStyle xmlns:a="http://schemas.openxmlformats.org/drawingml/2006/main"/>
           <a:p xmlns:a="http://schemas.openxmlformats.org/drawingml/2006/main">
             <a:pPr algn="l">
+              <a:buNone/>
               <a:defRPr sz="1425" b="0">
                 <a:solidFill>
                   <a:srgbClr val="F4F7FA"/>
@@ -11766,7 +11777,7 @@
                   <a:srgbClr val="F4F7FA"/>
                 </a:solidFill>
               </a:rPr>
-              <a:t>Maintain position for 10 fixed updates</a:t>
+              <a:t>Hold DRAFT for 6 fixed updates</a:t>
             </a:r>
           </a:p>
         </p:txBody>
@@ -11804,6 +11815,7 @@
           <a:lstStyle xmlns:a="http://schemas.openxmlformats.org/drawingml/2006/main"/>
           <a:p xmlns:a="http://schemas.openxmlformats.org/drawingml/2006/main">
             <a:pPr algn="l">
+              <a:buNone/>
               <a:defRPr sz="1650" b="1">
                 <a:solidFill>
                   <a:srgbClr val="FF35D3"/>
@@ -11887,6 +11899,7 @@
           <a:lstStyle xmlns:a="http://schemas.openxmlformats.org/drawingml/2006/main"/>
           <a:p xmlns:a="http://schemas.openxmlformats.org/drawingml/2006/main">
             <a:pPr algn="l">
+              <a:buNone/>
               <a:defRPr sz="1725" b="1">
                 <a:solidFill>
                   <a:srgbClr val="FF35D3"/>
@@ -11937,6 +11950,7 @@
           <a:lstStyle xmlns:a="http://schemas.openxmlformats.org/drawingml/2006/main"/>
           <a:p xmlns:a="http://schemas.openxmlformats.org/drawingml/2006/main">
             <a:pPr algn="l">
+              <a:buNone/>
               <a:defRPr sz="1425" b="0">
                 <a:solidFill>
                   <a:srgbClr val="F4F7FA"/>
@@ -11949,7 +11963,7 @@
                   <a:srgbClr val="F4F7FA"/>
                 </a:solidFill>
               </a:rPr>
-              <a:t>Recover 8 per update; the car brightens</a:t>
+              <a:t>Recover 12 per update; car and rear lines flash</a:t>
             </a:r>
           </a:p>
         </p:txBody>
@@ -12020,6 +12034,7 @@
           <a:lstStyle xmlns:a="http://schemas.openxmlformats.org/drawingml/2006/main"/>
           <a:p xmlns:a="http://schemas.openxmlformats.org/drawingml/2006/main">
             <a:pPr algn="l">
+              <a:buNone/>
               <a:defRPr sz="1350" b="1">
                 <a:solidFill>
                   <a:srgbClr val="00E6E6"/>
@@ -12032,7 +12047,7 @@
                   <a:srgbClr val="00E6E6"/>
                 </a:solidFill>
               </a:rPr>
-              <a:t>NEAR GAP  SLIPSTREAM</a:t>
+              <a:t>NEAR GAP  DRAFT &gt; SLIP</a:t>
             </a:r>
           </a:p>
         </p:txBody>
@@ -12070,6 +12085,7 @@
           <a:lstStyle xmlns:a="http://schemas.openxmlformats.org/drawingml/2006/main"/>
           <a:p xmlns:a="http://schemas.openxmlformats.org/drawingml/2006/main">
             <a:pPr algn="l">
+              <a:buNone/>
               <a:defRPr sz="1350" b="1">
                 <a:solidFill>
                   <a:srgbClr val="FFD34E"/>
@@ -12120,6 +12136,7 @@
           <a:lstStyle xmlns:a="http://schemas.openxmlformats.org/drawingml/2006/main"/>
           <a:p xmlns:a="http://schemas.openxmlformats.org/drawingml/2006/main">
             <a:pPr algn="r">
+              <a:buNone/>
               <a:defRPr sz="1350" b="1">
                 <a:solidFill>
                   <a:srgbClr val="FF35D3"/>
@@ -12170,6 +12187,7 @@
           <a:lstStyle xmlns:a="http://schemas.openxmlformats.org/drawingml/2006/main"/>
           <a:p xmlns:a="http://schemas.openxmlformats.org/drawingml/2006/main">
             <a:pPr algn="ctr">
+              <a:buNone/>
               <a:defRPr sz="1500" b="1">
                 <a:solidFill>
                   <a:srgbClr val="F4F7FA"/>
@@ -12182,7 +12200,7 @@
                   <a:srgbClr val="F4F7FA"/>
                 </a:solidFill>
               </a:rPr>
-              <a:t>Wait for the bright-car signal, then spend BOOST to move out and pass. Contact range ends recovery.</a:t>
+              <a:t>Hold DRAFT until SLIP blinks, then use BOOST to pass. Another lane, a one-eighth-lap gap, or contact ends recovery.</a:t>
             </a:r>
           </a:p>
         </p:txBody>
@@ -12253,6 +12271,7 @@
           <a:lstStyle xmlns:a="http://schemas.openxmlformats.org/drawingml/2006/main"/>
           <a:p xmlns:a="http://schemas.openxmlformats.org/drawingml/2006/main">
             <a:pPr algn="l">
+              <a:buNone/>
               <a:defRPr sz="975" b="1">
                 <a:solidFill>
                   <a:srgbClr val="78909C"/>
@@ -12303,6 +12322,7 @@
           <a:lstStyle xmlns:a="http://schemas.openxmlformats.org/drawingml/2006/main"/>
           <a:p xmlns:a="http://schemas.openxmlformats.org/drawingml/2006/main">
             <a:pPr algn="r">
+              <a:buNone/>
               <a:defRPr sz="975" b="0">
                 <a:solidFill>
                   <a:srgbClr val="78909C"/>

</xml_diff>

<commit_message>
Add SOUND TEST title menu and sound test mode
Expose a SOUND TEST entry on the title screen and implement a full sound-test mode. Adds GameModeSoundTest (src/gmsetest.*), integrates it into GameMode/Application/title flow, and updates title navigation to cycle 1P/2P/SOUND TEST with "SPACE SELECT" prompt. Introduces GameMode::consume_sound_label and Application handling to play sounds by label. Extends SoundEffect with play(label), label_count(), label_at(), and a labels table. Also updates manuals (EN/JA/PDF/PPTX) and progress notes, plus minor sound-sequence and include fixes.
</commit_message>
<xml_diff>
--- a/doc/manual-en.pptx
+++ b/doc/manual-en.pptx
@@ -2,29 +2,29 @@
 <file path=ppt/presentation.xml><?xml version="1.0" encoding="utf-8"?>
 <p:presentation xmlns:p="http://schemas.openxmlformats.org/presentationml/2006/main">
   <p:sldMasterIdLst>
-    <p:sldMasterId xmlns:r="http://schemas.openxmlformats.org/officeDocument/2006/relationships" id="2147483648" r:id="R5d117c146cce47dc"/>
+    <p:sldMasterId xmlns:r="http://schemas.openxmlformats.org/officeDocument/2006/relationships" id="2147483648" r:id="Re43b84825ec74e17"/>
   </p:sldMasterIdLst>
   <p:notesMasterIdLst>
-    <p:notesMasterId xmlns:r="http://schemas.openxmlformats.org/officeDocument/2006/relationships" r:id="R95414a97143045a6"/>
+    <p:notesMasterId xmlns:r="http://schemas.openxmlformats.org/officeDocument/2006/relationships" r:id="R602b5a1ba395416d"/>
   </p:notesMasterIdLst>
   <p:sldIdLst>
-    <p:sldId xmlns:r="http://schemas.openxmlformats.org/officeDocument/2006/relationships" id="256" r:id="R086daf6cb1064afd"/>
-    <p:sldId xmlns:r="http://schemas.openxmlformats.org/officeDocument/2006/relationships" id="257" r:id="R2f1b0f97cb474dfc"/>
-    <p:sldId xmlns:r="http://schemas.openxmlformats.org/officeDocument/2006/relationships" id="258" r:id="Rd5f55d8890bb46d7"/>
-    <p:sldId xmlns:r="http://schemas.openxmlformats.org/officeDocument/2006/relationships" id="259" r:id="R54120df537e24d56"/>
-    <p:sldId xmlns:r="http://schemas.openxmlformats.org/officeDocument/2006/relationships" id="260" r:id="Ra10989eb920a43d5"/>
-    <p:sldId xmlns:r="http://schemas.openxmlformats.org/officeDocument/2006/relationships" id="261" r:id="Rd740034af930479b"/>
-    <p:sldId xmlns:r="http://schemas.openxmlformats.org/officeDocument/2006/relationships" id="262" r:id="R65898f9fba8e48ac"/>
-    <p:sldId xmlns:r="http://schemas.openxmlformats.org/officeDocument/2006/relationships" id="263" r:id="R0da4e996257a4e4d"/>
-    <p:sldId xmlns:r="http://schemas.openxmlformats.org/officeDocument/2006/relationships" id="264" r:id="R2481b3f0d7b24a9c"/>
-    <p:sldId xmlns:r="http://schemas.openxmlformats.org/officeDocument/2006/relationships" id="265" r:id="Rd0f0c3d8796542da"/>
-    <p:sldId xmlns:r="http://schemas.openxmlformats.org/officeDocument/2006/relationships" id="266" r:id="R3ffe652865644f7c"/>
-    <p:sldId xmlns:r="http://schemas.openxmlformats.org/officeDocument/2006/relationships" id="267" r:id="Rd8b57125f4f44de5"/>
-    <p:sldId xmlns:r="http://schemas.openxmlformats.org/officeDocument/2006/relationships" id="268" r:id="R625fd9013459409a"/>
-    <p:sldId xmlns:r="http://schemas.openxmlformats.org/officeDocument/2006/relationships" id="269" r:id="R9fc2e7e308904aa3"/>
-    <p:sldId xmlns:r="http://schemas.openxmlformats.org/officeDocument/2006/relationships" id="270" r:id="R93085856b4fb4b4f"/>
-    <p:sldId xmlns:r="http://schemas.openxmlformats.org/officeDocument/2006/relationships" id="271" r:id="Rac3c541a96224d62"/>
-    <p:sldId xmlns:r="http://schemas.openxmlformats.org/officeDocument/2006/relationships" id="272" r:id="Rc0c2f79677a44d1e"/>
+    <p:sldId xmlns:r="http://schemas.openxmlformats.org/officeDocument/2006/relationships" id="256" r:id="R4f1fdee752f44596"/>
+    <p:sldId xmlns:r="http://schemas.openxmlformats.org/officeDocument/2006/relationships" id="257" r:id="R7c7ac21a3922403c"/>
+    <p:sldId xmlns:r="http://schemas.openxmlformats.org/officeDocument/2006/relationships" id="258" r:id="R1d6658a870564ffc"/>
+    <p:sldId xmlns:r="http://schemas.openxmlformats.org/officeDocument/2006/relationships" id="259" r:id="Rfbca81588f5b4029"/>
+    <p:sldId xmlns:r="http://schemas.openxmlformats.org/officeDocument/2006/relationships" id="260" r:id="Rd49eac04a503411b"/>
+    <p:sldId xmlns:r="http://schemas.openxmlformats.org/officeDocument/2006/relationships" id="261" r:id="R5003456d169c43ef"/>
+    <p:sldId xmlns:r="http://schemas.openxmlformats.org/officeDocument/2006/relationships" id="262" r:id="R972573cd7a8444d6"/>
+    <p:sldId xmlns:r="http://schemas.openxmlformats.org/officeDocument/2006/relationships" id="263" r:id="R8f50d93129af4cf0"/>
+    <p:sldId xmlns:r="http://schemas.openxmlformats.org/officeDocument/2006/relationships" id="264" r:id="R68aa67a6beb449a0"/>
+    <p:sldId xmlns:r="http://schemas.openxmlformats.org/officeDocument/2006/relationships" id="265" r:id="R139aebacb62b4641"/>
+    <p:sldId xmlns:r="http://schemas.openxmlformats.org/officeDocument/2006/relationships" id="266" r:id="R43f1b2d0bdff4fe2"/>
+    <p:sldId xmlns:r="http://schemas.openxmlformats.org/officeDocument/2006/relationships" id="267" r:id="R96eb199d20e44807"/>
+    <p:sldId xmlns:r="http://schemas.openxmlformats.org/officeDocument/2006/relationships" id="268" r:id="R8910344aabb84bb5"/>
+    <p:sldId xmlns:r="http://schemas.openxmlformats.org/officeDocument/2006/relationships" id="269" r:id="R6285059e17f244ac"/>
+    <p:sldId xmlns:r="http://schemas.openxmlformats.org/officeDocument/2006/relationships" id="270" r:id="R691b95d534924206"/>
+    <p:sldId xmlns:r="http://schemas.openxmlformats.org/officeDocument/2006/relationships" id="271" r:id="R5ede31bf45474b27"/>
+    <p:sldId xmlns:r="http://schemas.openxmlformats.org/officeDocument/2006/relationships" id="272" r:id="Ra86d0db1066f4689"/>
   </p:sldIdLst>
   <p:sldSz cx="11430000" cy="8572500"/>
   <p:notesSz cx="6858000" cy="9144000"/>
@@ -1578,7 +1578,7 @@
   </p:cSld>
   <p:clrMap bg1="lt1" tx1="dk1" bg2="lt2" tx2="dk2" accent1="accent1" accent2="accent2" accent3="accent3" accent4="accent4" accent5="accent5" accent6="accent6" hlink="hlink" folHlink="folHlink"/>
   <p:sldLayoutIdLst>
-    <p:sldLayoutId xmlns:r="http://schemas.openxmlformats.org/officeDocument/2006/relationships" id="2147483649" r:id="R4d2a039fe0c744d4"/>
+    <p:sldLayoutId xmlns:r="http://schemas.openxmlformats.org/officeDocument/2006/relationships" id="2147483649" r:id="Rd87591db0aef4444"/>
   </p:sldLayoutIdLst>
   <p:txStyles>
     <p:titleStyle>
@@ -16685,7 +16685,7 @@
                   <a:srgbClr val="F3FBFF"/>
                 </a:solidFill>
               </a:rPr>
-              <a:t>Choose a course on the way from title to START</a:t>
+              <a:t>Choose racing or SOUND TEST at the title</a:t>
             </a:r>
           </a:p>
         </p:txBody>
@@ -16772,7 +16772,7 @@
                   <a:srgbClr val="F3FBFF"/>
                 </a:solidFill>
               </a:rPr>
-              <a:t>SELECT MODE</a:t>
+              <a:t>1P / 2P / SE</a:t>
             </a:r>
           </a:p>
         </p:txBody>
@@ -17383,7 +17383,7 @@
                   <a:srgbClr val="F3FBFF"/>
                 </a:solidFill>
               </a:rPr>
-              <a:t>Up/down selects 1P or 2P</a:t>
+              <a:t>Up/down: 1P, 2P, or SOUND TEST</a:t>
             </a:r>
           </a:p>
         </p:txBody>
@@ -17522,7 +17522,7 @@
                   <a:srgbClr val="F3FBFF"/>
                 </a:solidFill>
               </a:rPr>
-              <a:t>Left/right changes CPU LEVEL</a:t>
+              <a:t>1P: left/right changes CPU LEVEL</a:t>
             </a:r>
           </a:p>
         </p:txBody>
@@ -17661,7 +17661,7 @@
                   <a:srgbClr val="F3FBFF"/>
                 </a:solidFill>
               </a:rPr>
-              <a:t>Confirm, then select a course</a:t>
+              <a:t>Race: choose course, then review controls</a:t>
             </a:r>
           </a:p>
         </p:txBody>
@@ -17800,7 +17800,7 @@
                   <a:srgbClr val="F3FBFF"/>
                 </a:solidFill>
               </a:rPr>
-              <a:t>Review controls, then READY</a:t>
+              <a:t>Sound Test: left/right, then SPACE to play</a:t>
             </a:r>
           </a:p>
         </p:txBody>
@@ -23227,7 +23227,7 @@
                   <a:srgbClr val="F3FBFF"/>
                 </a:solidFill>
               </a:rPr>
-              <a:t>Winner and lap counts remain visible for about five seconds.</a:t>
+              <a:t>A winner-specific fanfare plays; results remain for about five seconds.</a:t>
             </a:r>
           </a:p>
         </p:txBody>
@@ -23314,7 +23314,7 @@
                   <a:srgbClr val="FFD35A"/>
                 </a:solidFill>
               </a:rPr>
-              <a:t>INPUT RELEASE</a:t>
+              <a:t>COUNTDOWN + INPUT</a:t>
             </a:r>
           </a:p>
         </p:txBody>
@@ -23368,7 +23368,7 @@
                   <a:srgbClr val="F3FBFF"/>
                 </a:solidFill>
               </a:rPr>
-              <a:t>The return timer waits until finish-line inputs are released.</a:t>
+              <a:t>3, 2, 1 sound every 0.75 s. Controls unlock at START; release after finish.</a:t>
             </a:r>
           </a:p>
         </p:txBody>

</xml_diff>

<commit_message>
Document result and audio behavior
Updated the English and Japanese manuals to match the current game flow: result screens now require held input to be released before accepting any key or pad input to return to title, and the title/ESC/Button 2 controls were clarified. The sound test section now explains BGM/SE navigation, unavailable public-build BGM, and the licensed private-build track changes for title, final lap, and result music.
</commit_message>
<xml_diff>
--- a/doc/manual-en.pptx
+++ b/doc/manual-en.pptx
@@ -2,29 +2,29 @@
 <file path=ppt/presentation.xml><?xml version="1.0" encoding="utf-8"?>
 <p:presentation xmlns:p="http://schemas.openxmlformats.org/presentationml/2006/main">
   <p:sldMasterIdLst>
-    <p:sldMasterId xmlns:r="http://schemas.openxmlformats.org/officeDocument/2006/relationships" id="2147483648" r:id="Re43b84825ec74e17"/>
+    <p:sldMasterId xmlns:r="http://schemas.openxmlformats.org/officeDocument/2006/relationships" id="2147483648" r:id="R7a0cfed49edc40cb"/>
   </p:sldMasterIdLst>
   <p:notesMasterIdLst>
-    <p:notesMasterId xmlns:r="http://schemas.openxmlformats.org/officeDocument/2006/relationships" r:id="R602b5a1ba395416d"/>
+    <p:notesMasterId xmlns:r="http://schemas.openxmlformats.org/officeDocument/2006/relationships" r:id="R2ddd304339424440"/>
   </p:notesMasterIdLst>
   <p:sldIdLst>
-    <p:sldId xmlns:r="http://schemas.openxmlformats.org/officeDocument/2006/relationships" id="256" r:id="R4f1fdee752f44596"/>
-    <p:sldId xmlns:r="http://schemas.openxmlformats.org/officeDocument/2006/relationships" id="257" r:id="R7c7ac21a3922403c"/>
-    <p:sldId xmlns:r="http://schemas.openxmlformats.org/officeDocument/2006/relationships" id="258" r:id="R1d6658a870564ffc"/>
-    <p:sldId xmlns:r="http://schemas.openxmlformats.org/officeDocument/2006/relationships" id="259" r:id="Rfbca81588f5b4029"/>
-    <p:sldId xmlns:r="http://schemas.openxmlformats.org/officeDocument/2006/relationships" id="260" r:id="Rd49eac04a503411b"/>
-    <p:sldId xmlns:r="http://schemas.openxmlformats.org/officeDocument/2006/relationships" id="261" r:id="R5003456d169c43ef"/>
-    <p:sldId xmlns:r="http://schemas.openxmlformats.org/officeDocument/2006/relationships" id="262" r:id="R972573cd7a8444d6"/>
-    <p:sldId xmlns:r="http://schemas.openxmlformats.org/officeDocument/2006/relationships" id="263" r:id="R8f50d93129af4cf0"/>
-    <p:sldId xmlns:r="http://schemas.openxmlformats.org/officeDocument/2006/relationships" id="264" r:id="R68aa67a6beb449a0"/>
-    <p:sldId xmlns:r="http://schemas.openxmlformats.org/officeDocument/2006/relationships" id="265" r:id="R139aebacb62b4641"/>
-    <p:sldId xmlns:r="http://schemas.openxmlformats.org/officeDocument/2006/relationships" id="266" r:id="R43f1b2d0bdff4fe2"/>
-    <p:sldId xmlns:r="http://schemas.openxmlformats.org/officeDocument/2006/relationships" id="267" r:id="R96eb199d20e44807"/>
-    <p:sldId xmlns:r="http://schemas.openxmlformats.org/officeDocument/2006/relationships" id="268" r:id="R8910344aabb84bb5"/>
-    <p:sldId xmlns:r="http://schemas.openxmlformats.org/officeDocument/2006/relationships" id="269" r:id="R6285059e17f244ac"/>
-    <p:sldId xmlns:r="http://schemas.openxmlformats.org/officeDocument/2006/relationships" id="270" r:id="R691b95d534924206"/>
-    <p:sldId xmlns:r="http://schemas.openxmlformats.org/officeDocument/2006/relationships" id="271" r:id="R5ede31bf45474b27"/>
-    <p:sldId xmlns:r="http://schemas.openxmlformats.org/officeDocument/2006/relationships" id="272" r:id="Ra86d0db1066f4689"/>
+    <p:sldId xmlns:r="http://schemas.openxmlformats.org/officeDocument/2006/relationships" id="256" r:id="R0cf25fbe523e447f"/>
+    <p:sldId xmlns:r="http://schemas.openxmlformats.org/officeDocument/2006/relationships" id="257" r:id="R212c86daa1fd4633"/>
+    <p:sldId xmlns:r="http://schemas.openxmlformats.org/officeDocument/2006/relationships" id="258" r:id="R5cf79e8dc24d4a15"/>
+    <p:sldId xmlns:r="http://schemas.openxmlformats.org/officeDocument/2006/relationships" id="259" r:id="R6829dc811e384fa8"/>
+    <p:sldId xmlns:r="http://schemas.openxmlformats.org/officeDocument/2006/relationships" id="260" r:id="R44c0c1c97ac3435c"/>
+    <p:sldId xmlns:r="http://schemas.openxmlformats.org/officeDocument/2006/relationships" id="261" r:id="R342e05c421b34a4e"/>
+    <p:sldId xmlns:r="http://schemas.openxmlformats.org/officeDocument/2006/relationships" id="262" r:id="Rd2610abfac224708"/>
+    <p:sldId xmlns:r="http://schemas.openxmlformats.org/officeDocument/2006/relationships" id="263" r:id="Rff455b0554de4179"/>
+    <p:sldId xmlns:r="http://schemas.openxmlformats.org/officeDocument/2006/relationships" id="264" r:id="R536fbea8b02349a9"/>
+    <p:sldId xmlns:r="http://schemas.openxmlformats.org/officeDocument/2006/relationships" id="265" r:id="R5dc4b72b72624228"/>
+    <p:sldId xmlns:r="http://schemas.openxmlformats.org/officeDocument/2006/relationships" id="266" r:id="R458dda3753ae469c"/>
+    <p:sldId xmlns:r="http://schemas.openxmlformats.org/officeDocument/2006/relationships" id="267" r:id="R5246fd0716d94b8b"/>
+    <p:sldId xmlns:r="http://schemas.openxmlformats.org/officeDocument/2006/relationships" id="268" r:id="R95d28bcf217f4335"/>
+    <p:sldId xmlns:r="http://schemas.openxmlformats.org/officeDocument/2006/relationships" id="269" r:id="Rd8f50217e62746a3"/>
+    <p:sldId xmlns:r="http://schemas.openxmlformats.org/officeDocument/2006/relationships" id="270" r:id="R3bdb3f2a5f7c4db1"/>
+    <p:sldId xmlns:r="http://schemas.openxmlformats.org/officeDocument/2006/relationships" id="271" r:id="R454ff383a025492f"/>
+    <p:sldId xmlns:r="http://schemas.openxmlformats.org/officeDocument/2006/relationships" id="272" r:id="R116658e572af4ed3"/>
   </p:sldIdLst>
   <p:sldSz cx="11430000" cy="8572500"/>
   <p:notesSz cx="6858000" cy="9144000"/>
@@ -1578,7 +1578,7 @@
   </p:cSld>
   <p:clrMap bg1="lt1" tx1="dk1" bg2="lt2" tx2="dk2" accent1="accent1" accent2="accent2" accent3="accent3" accent4="accent4" accent5="accent5" accent6="accent6" hlink="hlink" folHlink="folHlink"/>
   <p:sldLayoutIdLst>
-    <p:sldLayoutId xmlns:r="http://schemas.openxmlformats.org/officeDocument/2006/relationships" id="2147483649" r:id="Rd87591db0aef4444"/>
+    <p:sldLayoutId xmlns:r="http://schemas.openxmlformats.org/officeDocument/2006/relationships" id="2147483649" r:id="Rb3b06a6874ea4c23"/>
   </p:sldLayoutIdLst>
   <p:txStyles>
     <p:titleStyle>
@@ -16772,7 +16772,7 @@
                   <a:srgbClr val="F3FBFF"/>
                 </a:solidFill>
               </a:rPr>
-              <a:t>1P / 2P / SE</a:t>
+              <a:t>1P / 2P / SOUND</a:t>
             </a:r>
           </a:p>
         </p:txBody>
@@ -17800,7 +17800,7 @@
                   <a:srgbClr val="F3FBFF"/>
                 </a:solidFill>
               </a:rPr>
-              <a:t>Sound Test: left/right, then SPACE to play</a:t>
+              <a:t>Sound Test: up/down BGM-SE, left/right select, SPACE play</a:t>
             </a:r>
           </a:p>
         </p:txBody>
@@ -18858,7 +18858,7 @@
                   <a:srgbClr val="F4F7FA"/>
                 </a:solidFill>
               </a:rPr>
-              <a:t>LEFT / RIGHT  SELECT     SPACE / BUTTON 1  CONFIRM     ESC  TITLE</a:t>
+              <a:t>LEFT / RIGHT  SELECT     SPACE / BUTTON 1  CONFIRM     ESC / B2  TITLE</a:t>
             </a:r>
           </a:p>
         </p:txBody>
@@ -20885,7 +20885,7 @@
                   <a:srgbClr val="FFD35A"/>
                 </a:solidFill>
               </a:rPr>
-              <a:t>ESC</a:t>
+              <a:t>ESC / B2</a:t>
             </a:r>
           </a:p>
         </p:txBody>
@@ -23227,7 +23227,7 @@
                   <a:srgbClr val="F3FBFF"/>
                 </a:solidFill>
               </a:rPr>
-              <a:t>A winner-specific fanfare plays; results remain for about five seconds.</a:t>
+              <a:t>Release held input, then press any key at PRESS ANY KEY. No auto return.</a:t>
             </a:r>
           </a:p>
         </p:txBody>
@@ -23368,7 +23368,7 @@
                   <a:srgbClr val="F3FBFF"/>
                 </a:solidFill>
               </a:rPr>
-              <a:t>3, 2, 1 sound every 0.75 s. Controls unlock at START; release after finish.</a:t>
+              <a:t>3, 2, 1 sound every 0.75 s. START unlocks control; FINAL LAP changes BGM.</a:t>
             </a:r>
           </a:p>
         </p:txBody>
@@ -23455,7 +23455,7 @@
                   <a:srgbClr val="648BFF"/>
                 </a:solidFill>
               </a:rPr>
-              <a:t>ESC</a:t>
+              <a:t>ESC / B2</a:t>
             </a:r>
           </a:p>
         </p:txBody>

</xml_diff>